<commit_message>
Match welding deck styling to presentation 4 layout
Use Презентация_4_обновленная as visual template: Inter sizes
11/30/16/14, no accent bar or side images, clean red list layout.

Co-authored-by: lysakalenushka-hash <lysakalenushka-hash@users.noreply.github.com>
</commit_message>
<xml_diff>
--- a/Презентация_Сварочные_работы.pptx
+++ b/Презентация_Сварочные_работы.pptx
@@ -3215,7 +3215,7 @@
           <a:p>
             <a:pPr algn="l"/>
             <a:r>
-              <a:rPr sz="2600" b="1">
+              <a:rPr sz="3000" b="1">
                 <a:solidFill>
                   <a:srgbClr val="1A1A1A"/>
                 </a:solidFill>
@@ -3250,7 +3250,7 @@
           <a:p>
             <a:pPr algn="l"/>
             <a:r>
-              <a:rPr sz="1300" b="0">
+              <a:rPr sz="1600" b="0">
                 <a:solidFill>
                   <a:srgbClr val="6B7280"/>
                 </a:solidFill>
@@ -3355,7 +3355,7 @@
           <a:p>
             <a:pPr algn="l"/>
             <a:r>
-              <a:rPr sz="1300" b="1">
+              <a:rPr sz="1400" b="1">
                 <a:solidFill>
                   <a:srgbClr val="F59E0B"/>
                 </a:solidFill>
@@ -3436,73 +3436,6 @@
           </a:p>
         </p:txBody>
       </p:sp>
-      <p:sp>
-        <p:nvSpPr>
-          <p:cNvPr id="11" name="Rectangle 10"/>
-          <p:cNvSpPr/>
-          <p:nvPr/>
-        </p:nvSpPr>
-        <p:spPr>
-          <a:xfrm>
-            <a:off x="0" y="0"/>
-            <a:ext cx="90000" cy="6858000"/>
-          </a:xfrm>
-          <a:prstGeom prst="rect">
-            <a:avLst/>
-          </a:prstGeom>
-          <a:solidFill>
-            <a:srgbClr val="E30613"/>
-          </a:solidFill>
-          <a:ln>
-            <a:noFill/>
-          </a:ln>
-        </p:spPr>
-        <p:style>
-          <a:lnRef idx="1">
-            <a:schemeClr val="accent1"/>
-          </a:lnRef>
-          <a:fillRef idx="3">
-            <a:schemeClr val="accent1"/>
-          </a:fillRef>
-          <a:effectRef idx="2">
-            <a:schemeClr val="accent1"/>
-          </a:effectRef>
-          <a:fontRef idx="minor">
-            <a:schemeClr val="lt1"/>
-          </a:fontRef>
-        </p:style>
-        <p:txBody>
-          <a:bodyPr rtlCol="0" anchor="ctr"/>
-          <a:lstStyle/>
-          <a:p>
-            <a:pPr algn="ctr"/>
-          </a:p>
-        </p:txBody>
-      </p:sp>
-      <p:pic>
-        <p:nvPicPr>
-          <p:cNvPr id="12" name="Picture 11" descr="arc.jpg"/>
-          <p:cNvPicPr>
-            <a:picLocks noChangeAspect="1"/>
-          </p:cNvPicPr>
-          <p:nvPr/>
-        </p:nvPicPr>
-        <p:blipFill>
-          <a:blip r:embed="rId2"/>
-          <a:stretch>
-            <a:fillRect/>
-          </a:stretch>
-        </p:blipFill>
-        <p:spPr>
-          <a:xfrm>
-            <a:off x="7200000" y="2200000"/>
-            <a:ext cx="4500000" cy="3600000"/>
-          </a:xfrm>
-          <a:prstGeom prst="rect">
-            <a:avLst/>
-          </a:prstGeom>
-        </p:spPr>
-      </p:pic>
     </p:spTree>
   </p:cSld>
   <p:clrMapOvr>
@@ -3624,7 +3557,7 @@
           <a:p>
             <a:pPr algn="l"/>
             <a:r>
-              <a:rPr sz="2400" b="1">
+              <a:rPr sz="3000" b="1">
                 <a:solidFill>
                   <a:srgbClr val="1A1A1A"/>
                 </a:solidFill>
@@ -3659,7 +3592,7 @@
           <a:p>
             <a:pPr algn="l"/>
             <a:r>
-              <a:rPr sz="1300" b="0">
+              <a:rPr sz="1600" b="0">
                 <a:solidFill>
                   <a:srgbClr val="6B7280"/>
                 </a:solidFill>
@@ -3694,7 +3627,7 @@
           <a:p>
             <a:pPr algn="l"/>
             <a:r>
-              <a:rPr sz="1200" b="1">
+              <a:rPr sz="1100" b="1">
                 <a:solidFill>
                   <a:srgbClr val="E30613"/>
                 </a:solidFill>
@@ -3764,7 +3697,7 @@
           <a:p>
             <a:pPr algn="l"/>
             <a:r>
-              <a:rPr sz="1600" b="1">
+              <a:rPr sz="1400" b="1">
                 <a:solidFill>
                   <a:srgbClr val="E30613"/>
                 </a:solidFill>
@@ -3799,7 +3732,7 @@
           <a:p>
             <a:pPr algn="l"/>
             <a:r>
-              <a:rPr sz="1300" b="0">
+              <a:rPr sz="1400" b="0">
                 <a:solidFill>
                   <a:srgbClr val="1A1A1A"/>
                 </a:solidFill>
@@ -3834,7 +3767,7 @@
           <a:p>
             <a:pPr algn="l"/>
             <a:r>
-              <a:rPr sz="1600" b="1">
+              <a:rPr sz="1400" b="1">
                 <a:solidFill>
                   <a:srgbClr val="E30613"/>
                 </a:solidFill>
@@ -3869,7 +3802,7 @@
           <a:p>
             <a:pPr algn="l"/>
             <a:r>
-              <a:rPr sz="1300" b="0">
+              <a:rPr sz="1400" b="0">
                 <a:solidFill>
                   <a:srgbClr val="1A1A1A"/>
                 </a:solidFill>
@@ -4044,9 +3977,9 @@
           <a:p>
             <a:pPr algn="l"/>
             <a:r>
-              <a:rPr sz="900" b="0">
-                <a:solidFill>
-                  <a:srgbClr val="6B7280"/>
+              <a:rPr sz="1200" b="0">
+                <a:solidFill>
+                  <a:srgbClr val="1A1A1A"/>
                 </a:solidFill>
                 <a:latin typeface="Inter"/>
               </a:rPr>
@@ -4210,49 +4143,6 @@
               </a:rPr>
               <a:t>10 / 25</a:t>
             </a:r>
-          </a:p>
-        </p:txBody>
-      </p:sp>
-      <p:sp>
-        <p:nvSpPr>
-          <p:cNvPr id="21" name="Rectangle 20"/>
-          <p:cNvSpPr/>
-          <p:nvPr/>
-        </p:nvSpPr>
-        <p:spPr>
-          <a:xfrm>
-            <a:off x="0" y="0"/>
-            <a:ext cx="90000" cy="6858000"/>
-          </a:xfrm>
-          <a:prstGeom prst="rect">
-            <a:avLst/>
-          </a:prstGeom>
-          <a:solidFill>
-            <a:srgbClr val="E30613"/>
-          </a:solidFill>
-          <a:ln>
-            <a:noFill/>
-          </a:ln>
-        </p:spPr>
-        <p:style>
-          <a:lnRef idx="1">
-            <a:schemeClr val="accent1"/>
-          </a:lnRef>
-          <a:fillRef idx="3">
-            <a:schemeClr val="accent1"/>
-          </a:fillRef>
-          <a:effectRef idx="2">
-            <a:schemeClr val="accent1"/>
-          </a:effectRef>
-          <a:fontRef idx="minor">
-            <a:schemeClr val="lt1"/>
-          </a:fontRef>
-        </p:style>
-        <p:txBody>
-          <a:bodyPr rtlCol="0" anchor="ctr"/>
-          <a:lstStyle/>
-          <a:p>
-            <a:pPr algn="ctr"/>
           </a:p>
         </p:txBody>
       </p:sp>
@@ -4377,7 +4267,7 @@
           <a:p>
             <a:pPr algn="l"/>
             <a:r>
-              <a:rPr sz="2400" b="1">
+              <a:rPr sz="3000" b="1">
                 <a:solidFill>
                   <a:srgbClr val="1A1A1A"/>
                 </a:solidFill>
@@ -4412,7 +4302,7 @@
           <a:p>
             <a:pPr algn="l"/>
             <a:r>
-              <a:rPr sz="1300" b="0">
+              <a:rPr sz="1600" b="0">
                 <a:solidFill>
                   <a:srgbClr val="6B7280"/>
                 </a:solidFill>
@@ -4447,7 +4337,7 @@
           <a:p>
             <a:pPr algn="l"/>
             <a:r>
-              <a:rPr sz="1200" b="1">
+              <a:rPr sz="1100" b="1">
                 <a:solidFill>
                   <a:srgbClr val="E30613"/>
                 </a:solidFill>
@@ -4517,7 +4407,7 @@
           <a:p>
             <a:pPr algn="l"/>
             <a:r>
-              <a:rPr sz="1600" b="1">
+              <a:rPr sz="1400" b="1">
                 <a:solidFill>
                   <a:srgbClr val="E30613"/>
                 </a:solidFill>
@@ -4552,7 +4442,7 @@
           <a:p>
             <a:pPr algn="l"/>
             <a:r>
-              <a:rPr sz="1300" b="0">
+              <a:rPr sz="1400" b="0">
                 <a:solidFill>
                   <a:srgbClr val="1A1A1A"/>
                 </a:solidFill>
@@ -4587,7 +4477,7 @@
           <a:p>
             <a:pPr algn="l"/>
             <a:r>
-              <a:rPr sz="1600" b="1">
+              <a:rPr sz="1400" b="1">
                 <a:solidFill>
                   <a:srgbClr val="E30613"/>
                 </a:solidFill>
@@ -4622,7 +4512,7 @@
           <a:p>
             <a:pPr algn="l"/>
             <a:r>
-              <a:rPr sz="1300" b="0">
+              <a:rPr sz="1400" b="0">
                 <a:solidFill>
                   <a:srgbClr val="1A1A1A"/>
                 </a:solidFill>
@@ -4657,7 +4547,7 @@
           <a:p>
             <a:pPr algn="l"/>
             <a:r>
-              <a:rPr sz="1600" b="1">
+              <a:rPr sz="1400" b="1">
                 <a:solidFill>
                   <a:srgbClr val="E30613"/>
                 </a:solidFill>
@@ -4692,7 +4582,7 @@
           <a:p>
             <a:pPr algn="l"/>
             <a:r>
-              <a:rPr sz="1300" b="0">
+              <a:rPr sz="1400" b="0">
                 <a:solidFill>
                   <a:srgbClr val="1A1A1A"/>
                 </a:solidFill>
@@ -4727,7 +4617,7 @@
           <a:p>
             <a:pPr algn="l"/>
             <a:r>
-              <a:rPr sz="1600" b="1">
+              <a:rPr sz="1400" b="1">
                 <a:solidFill>
                   <a:srgbClr val="E30613"/>
                 </a:solidFill>
@@ -4762,7 +4652,7 @@
           <a:p>
             <a:pPr algn="l"/>
             <a:r>
-              <a:rPr sz="1300" b="0">
+              <a:rPr sz="1400" b="0">
                 <a:solidFill>
                   <a:srgbClr val="1A1A1A"/>
                 </a:solidFill>
@@ -4797,9 +4687,9 @@
           <a:p>
             <a:pPr algn="l"/>
             <a:r>
-              <a:rPr sz="900" b="0">
-                <a:solidFill>
-                  <a:srgbClr val="6B7280"/>
+              <a:rPr sz="1200" b="0">
+                <a:solidFill>
+                  <a:srgbClr val="1A1A1A"/>
                 </a:solidFill>
                 <a:latin typeface="Inter"/>
               </a:rPr>
@@ -4966,73 +4856,6 @@
           </a:p>
         </p:txBody>
       </p:sp>
-      <p:sp>
-        <p:nvSpPr>
-          <p:cNvPr id="21" name="Rectangle 20"/>
-          <p:cNvSpPr/>
-          <p:nvPr/>
-        </p:nvSpPr>
-        <p:spPr>
-          <a:xfrm>
-            <a:off x="0" y="0"/>
-            <a:ext cx="90000" cy="6858000"/>
-          </a:xfrm>
-          <a:prstGeom prst="rect">
-            <a:avLst/>
-          </a:prstGeom>
-          <a:solidFill>
-            <a:srgbClr val="E30613"/>
-          </a:solidFill>
-          <a:ln>
-            <a:noFill/>
-          </a:ln>
-        </p:spPr>
-        <p:style>
-          <a:lnRef idx="1">
-            <a:schemeClr val="accent1"/>
-          </a:lnRef>
-          <a:fillRef idx="3">
-            <a:schemeClr val="accent1"/>
-          </a:fillRef>
-          <a:effectRef idx="2">
-            <a:schemeClr val="accent1"/>
-          </a:effectRef>
-          <a:fontRef idx="minor">
-            <a:schemeClr val="lt1"/>
-          </a:fontRef>
-        </p:style>
-        <p:txBody>
-          <a:bodyPr rtlCol="0" anchor="ctr"/>
-          <a:lstStyle/>
-          <a:p>
-            <a:pPr algn="ctr"/>
-          </a:p>
-        </p:txBody>
-      </p:sp>
-      <p:pic>
-        <p:nvPicPr>
-          <p:cNvPr id="22" name="Picture 21" descr="pipe_weld.jpg"/>
-          <p:cNvPicPr>
-            <a:picLocks noChangeAspect="1"/>
-          </p:cNvPicPr>
-          <p:nvPr/>
-        </p:nvPicPr>
-        <p:blipFill>
-          <a:blip r:embed="rId2"/>
-          <a:stretch>
-            <a:fillRect/>
-          </a:stretch>
-        </p:blipFill>
-        <p:spPr>
-          <a:xfrm>
-            <a:off x="7200000" y="2200000"/>
-            <a:ext cx="4500000" cy="3600000"/>
-          </a:xfrm>
-          <a:prstGeom prst="rect">
-            <a:avLst/>
-          </a:prstGeom>
-        </p:spPr>
-      </p:pic>
     </p:spTree>
   </p:cSld>
   <p:clrMapOvr>
@@ -5154,7 +4977,7 @@
           <a:p>
             <a:pPr algn="l"/>
             <a:r>
-              <a:rPr sz="2400" b="1">
+              <a:rPr sz="3000" b="1">
                 <a:solidFill>
                   <a:srgbClr val="1A1A1A"/>
                 </a:solidFill>
@@ -5189,7 +5012,7 @@
           <a:p>
             <a:pPr algn="l"/>
             <a:r>
-              <a:rPr sz="1300" b="0">
+              <a:rPr sz="1600" b="0">
                 <a:solidFill>
                   <a:srgbClr val="6B7280"/>
                 </a:solidFill>
@@ -5224,7 +5047,7 @@
           <a:p>
             <a:pPr algn="l"/>
             <a:r>
-              <a:rPr sz="1200" b="1">
+              <a:rPr sz="1100" b="1">
                 <a:solidFill>
                   <a:srgbClr val="E30613"/>
                 </a:solidFill>
@@ -5294,7 +5117,7 @@
           <a:p>
             <a:pPr algn="l"/>
             <a:r>
-              <a:rPr sz="1600" b="1">
+              <a:rPr sz="1400" b="1">
                 <a:solidFill>
                   <a:srgbClr val="E30613"/>
                 </a:solidFill>
@@ -5329,7 +5152,7 @@
           <a:p>
             <a:pPr algn="l"/>
             <a:r>
-              <a:rPr sz="1300" b="0">
+              <a:rPr sz="1400" b="0">
                 <a:solidFill>
                   <a:srgbClr val="1A1A1A"/>
                 </a:solidFill>
@@ -5364,7 +5187,7 @@
           <a:p>
             <a:pPr algn="l"/>
             <a:r>
-              <a:rPr sz="1600" b="1">
+              <a:rPr sz="1400" b="1">
                 <a:solidFill>
                   <a:srgbClr val="E30613"/>
                 </a:solidFill>
@@ -5399,7 +5222,7 @@
           <a:p>
             <a:pPr algn="l"/>
             <a:r>
-              <a:rPr sz="1300" b="0">
+              <a:rPr sz="1400" b="0">
                 <a:solidFill>
                   <a:srgbClr val="1A1A1A"/>
                 </a:solidFill>
@@ -5574,9 +5397,9 @@
           <a:p>
             <a:pPr algn="l"/>
             <a:r>
-              <a:rPr sz="900" b="0">
-                <a:solidFill>
-                  <a:srgbClr val="6B7280"/>
+              <a:rPr sz="1200" b="0">
+                <a:solidFill>
+                  <a:srgbClr val="1A1A1A"/>
                 </a:solidFill>
                 <a:latin typeface="Inter"/>
               </a:rPr>
@@ -5740,49 +5563,6 @@
               </a:rPr>
               <a:t>12 / 25</a:t>
             </a:r>
-          </a:p>
-        </p:txBody>
-      </p:sp>
-      <p:sp>
-        <p:nvSpPr>
-          <p:cNvPr id="21" name="Rectangle 20"/>
-          <p:cNvSpPr/>
-          <p:nvPr/>
-        </p:nvSpPr>
-        <p:spPr>
-          <a:xfrm>
-            <a:off x="0" y="0"/>
-            <a:ext cx="90000" cy="6858000"/>
-          </a:xfrm>
-          <a:prstGeom prst="rect">
-            <a:avLst/>
-          </a:prstGeom>
-          <a:solidFill>
-            <a:srgbClr val="E30613"/>
-          </a:solidFill>
-          <a:ln>
-            <a:noFill/>
-          </a:ln>
-        </p:spPr>
-        <p:style>
-          <a:lnRef idx="1">
-            <a:schemeClr val="accent1"/>
-          </a:lnRef>
-          <a:fillRef idx="3">
-            <a:schemeClr val="accent1"/>
-          </a:fillRef>
-          <a:effectRef idx="2">
-            <a:schemeClr val="accent1"/>
-          </a:effectRef>
-          <a:fontRef idx="minor">
-            <a:schemeClr val="lt1"/>
-          </a:fontRef>
-        </p:style>
-        <p:txBody>
-          <a:bodyPr rtlCol="0" anchor="ctr"/>
-          <a:lstStyle/>
-          <a:p>
-            <a:pPr algn="ctr"/>
           </a:p>
         </p:txBody>
       </p:sp>
@@ -5907,7 +5687,7 @@
           <a:p>
             <a:pPr algn="l"/>
             <a:r>
-              <a:rPr sz="2400" b="1">
+              <a:rPr sz="3000" b="1">
                 <a:solidFill>
                   <a:srgbClr val="1A1A1A"/>
                 </a:solidFill>
@@ -5942,7 +5722,7 @@
           <a:p>
             <a:pPr algn="l"/>
             <a:r>
-              <a:rPr sz="1300" b="0">
+              <a:rPr sz="1600" b="0">
                 <a:solidFill>
                   <a:srgbClr val="6B7280"/>
                 </a:solidFill>
@@ -5977,7 +5757,7 @@
           <a:p>
             <a:pPr algn="l"/>
             <a:r>
-              <a:rPr sz="1200" b="1">
+              <a:rPr sz="1100" b="1">
                 <a:solidFill>
                   <a:srgbClr val="E30613"/>
                 </a:solidFill>
@@ -6047,7 +5827,7 @@
           <a:p>
             <a:pPr algn="l"/>
             <a:r>
-              <a:rPr sz="1600" b="1">
+              <a:rPr sz="1400" b="1">
                 <a:solidFill>
                   <a:srgbClr val="E30613"/>
                 </a:solidFill>
@@ -6082,7 +5862,7 @@
           <a:p>
             <a:pPr algn="l"/>
             <a:r>
-              <a:rPr sz="1300" b="0">
+              <a:rPr sz="1400" b="0">
                 <a:solidFill>
                   <a:srgbClr val="1A1A1A"/>
                 </a:solidFill>
@@ -6117,7 +5897,7 @@
           <a:p>
             <a:pPr algn="l"/>
             <a:r>
-              <a:rPr sz="1600" b="1">
+              <a:rPr sz="1400" b="1">
                 <a:solidFill>
                   <a:srgbClr val="E30613"/>
                 </a:solidFill>
@@ -6152,7 +5932,7 @@
           <a:p>
             <a:pPr algn="l"/>
             <a:r>
-              <a:rPr sz="1300" b="0">
+              <a:rPr sz="1400" b="0">
                 <a:solidFill>
                   <a:srgbClr val="1A1A1A"/>
                 </a:solidFill>
@@ -6187,7 +5967,7 @@
           <a:p>
             <a:pPr algn="l"/>
             <a:r>
-              <a:rPr sz="1600" b="1">
+              <a:rPr sz="1400" b="1">
                 <a:solidFill>
                   <a:srgbClr val="E30613"/>
                 </a:solidFill>
@@ -6222,7 +6002,7 @@
           <a:p>
             <a:pPr algn="l"/>
             <a:r>
-              <a:rPr sz="1300" b="0">
+              <a:rPr sz="1400" b="0">
                 <a:solidFill>
                   <a:srgbClr val="1A1A1A"/>
                 </a:solidFill>
@@ -6257,7 +6037,7 @@
           <a:p>
             <a:pPr algn="l"/>
             <a:r>
-              <a:rPr sz="1600" b="1">
+              <a:rPr sz="1400" b="1">
                 <a:solidFill>
                   <a:srgbClr val="E30613"/>
                 </a:solidFill>
@@ -6292,7 +6072,7 @@
           <a:p>
             <a:pPr algn="l"/>
             <a:r>
-              <a:rPr sz="1300" b="0">
+              <a:rPr sz="1400" b="0">
                 <a:solidFill>
                   <a:srgbClr val="1A1A1A"/>
                 </a:solidFill>
@@ -6327,9 +6107,9 @@
           <a:p>
             <a:pPr algn="l"/>
             <a:r>
-              <a:rPr sz="900" b="0">
-                <a:solidFill>
-                  <a:srgbClr val="6B7280"/>
+              <a:rPr sz="1200" b="0">
+                <a:solidFill>
+                  <a:srgbClr val="1A1A1A"/>
                 </a:solidFill>
                 <a:latin typeface="Inter"/>
               </a:rPr>
@@ -6496,73 +6276,6 @@
           </a:p>
         </p:txBody>
       </p:sp>
-      <p:sp>
-        <p:nvSpPr>
-          <p:cNvPr id="21" name="Rectangle 20"/>
-          <p:cNvSpPr/>
-          <p:nvPr/>
-        </p:nvSpPr>
-        <p:spPr>
-          <a:xfrm>
-            <a:off x="0" y="0"/>
-            <a:ext cx="90000" cy="6858000"/>
-          </a:xfrm>
-          <a:prstGeom prst="rect">
-            <a:avLst/>
-          </a:prstGeom>
-          <a:solidFill>
-            <a:srgbClr val="E30613"/>
-          </a:solidFill>
-          <a:ln>
-            <a:noFill/>
-          </a:ln>
-        </p:spPr>
-        <p:style>
-          <a:lnRef idx="1">
-            <a:schemeClr val="accent1"/>
-          </a:lnRef>
-          <a:fillRef idx="3">
-            <a:schemeClr val="accent1"/>
-          </a:fillRef>
-          <a:effectRef idx="2">
-            <a:schemeClr val="accent1"/>
-          </a:effectRef>
-          <a:fontRef idx="minor">
-            <a:schemeClr val="lt1"/>
-          </a:fontRef>
-        </p:style>
-        <p:txBody>
-          <a:bodyPr rtlCol="0" anchor="ctr"/>
-          <a:lstStyle/>
-          <a:p>
-            <a:pPr algn="ctr"/>
-          </a:p>
-        </p:txBody>
-      </p:sp>
-      <p:pic>
-        <p:nvPicPr>
-          <p:cNvPr id="22" name="Picture 21" descr="mig.jpg"/>
-          <p:cNvPicPr>
-            <a:picLocks noChangeAspect="1"/>
-          </p:cNvPicPr>
-          <p:nvPr/>
-        </p:nvPicPr>
-        <p:blipFill>
-          <a:blip r:embed="rId2"/>
-          <a:stretch>
-            <a:fillRect/>
-          </a:stretch>
-        </p:blipFill>
-        <p:spPr>
-          <a:xfrm>
-            <a:off x="7200000" y="2200000"/>
-            <a:ext cx="4500000" cy="3600000"/>
-          </a:xfrm>
-          <a:prstGeom prst="rect">
-            <a:avLst/>
-          </a:prstGeom>
-        </p:spPr>
-      </p:pic>
     </p:spTree>
   </p:cSld>
   <p:clrMapOvr>
@@ -6684,7 +6397,7 @@
           <a:p>
             <a:pPr algn="l"/>
             <a:r>
-              <a:rPr sz="2400" b="1">
+              <a:rPr sz="3000" b="1">
                 <a:solidFill>
                   <a:srgbClr val="1A1A1A"/>
                 </a:solidFill>
@@ -6719,7 +6432,7 @@
           <a:p>
             <a:pPr algn="l"/>
             <a:r>
-              <a:rPr sz="1300" b="0">
+              <a:rPr sz="1600" b="0">
                 <a:solidFill>
                   <a:srgbClr val="6B7280"/>
                 </a:solidFill>
@@ -6754,7 +6467,7 @@
           <a:p>
             <a:pPr algn="l"/>
             <a:r>
-              <a:rPr sz="1200" b="1">
+              <a:rPr sz="1100" b="1">
                 <a:solidFill>
                   <a:srgbClr val="E30613"/>
                 </a:solidFill>
@@ -6824,7 +6537,7 @@
           <a:p>
             <a:pPr algn="l"/>
             <a:r>
-              <a:rPr sz="1600" b="1">
+              <a:rPr sz="1400" b="1">
                 <a:solidFill>
                   <a:srgbClr val="E30613"/>
                 </a:solidFill>
@@ -6859,7 +6572,7 @@
           <a:p>
             <a:pPr algn="l"/>
             <a:r>
-              <a:rPr sz="1300" b="0">
+              <a:rPr sz="1400" b="0">
                 <a:solidFill>
                   <a:srgbClr val="1A1A1A"/>
                 </a:solidFill>
@@ -6894,7 +6607,7 @@
           <a:p>
             <a:pPr algn="l"/>
             <a:r>
-              <a:rPr sz="1600" b="1">
+              <a:rPr sz="1400" b="1">
                 <a:solidFill>
                   <a:srgbClr val="E30613"/>
                 </a:solidFill>
@@ -6929,7 +6642,7 @@
           <a:p>
             <a:pPr algn="l"/>
             <a:r>
-              <a:rPr sz="1300" b="0">
+              <a:rPr sz="1400" b="0">
                 <a:solidFill>
                   <a:srgbClr val="1A1A1A"/>
                 </a:solidFill>
@@ -6964,7 +6677,7 @@
           <a:p>
             <a:pPr algn="l"/>
             <a:r>
-              <a:rPr sz="1600" b="1">
+              <a:rPr sz="1400" b="1">
                 <a:solidFill>
                   <a:srgbClr val="E30613"/>
                 </a:solidFill>
@@ -6999,7 +6712,7 @@
           <a:p>
             <a:pPr algn="l"/>
             <a:r>
-              <a:rPr sz="1300" b="0">
+              <a:rPr sz="1400" b="0">
                 <a:solidFill>
                   <a:srgbClr val="1A1A1A"/>
                 </a:solidFill>
@@ -7104,9 +6817,9 @@
           <a:p>
             <a:pPr algn="l"/>
             <a:r>
-              <a:rPr sz="900" b="0">
-                <a:solidFill>
-                  <a:srgbClr val="6B7280"/>
+              <a:rPr sz="1200" b="0">
+                <a:solidFill>
+                  <a:srgbClr val="1A1A1A"/>
                 </a:solidFill>
                 <a:latin typeface="Inter"/>
               </a:rPr>
@@ -7270,49 +6983,6 @@
               </a:rPr>
               <a:t>14 / 25</a:t>
             </a:r>
-          </a:p>
-        </p:txBody>
-      </p:sp>
-      <p:sp>
-        <p:nvSpPr>
-          <p:cNvPr id="21" name="Rectangle 20"/>
-          <p:cNvSpPr/>
-          <p:nvPr/>
-        </p:nvSpPr>
-        <p:spPr>
-          <a:xfrm>
-            <a:off x="0" y="0"/>
-            <a:ext cx="90000" cy="6858000"/>
-          </a:xfrm>
-          <a:prstGeom prst="rect">
-            <a:avLst/>
-          </a:prstGeom>
-          <a:solidFill>
-            <a:srgbClr val="E30613"/>
-          </a:solidFill>
-          <a:ln>
-            <a:noFill/>
-          </a:ln>
-        </p:spPr>
-        <p:style>
-          <a:lnRef idx="1">
-            <a:schemeClr val="accent1"/>
-          </a:lnRef>
-          <a:fillRef idx="3">
-            <a:schemeClr val="accent1"/>
-          </a:fillRef>
-          <a:effectRef idx="2">
-            <a:schemeClr val="accent1"/>
-          </a:effectRef>
-          <a:fontRef idx="minor">
-            <a:schemeClr val="lt1"/>
-          </a:fontRef>
-        </p:style>
-        <p:txBody>
-          <a:bodyPr rtlCol="0" anchor="ctr"/>
-          <a:lstStyle/>
-          <a:p>
-            <a:pPr algn="ctr"/>
           </a:p>
         </p:txBody>
       </p:sp>
@@ -7437,7 +7107,7 @@
           <a:p>
             <a:pPr algn="l"/>
             <a:r>
-              <a:rPr sz="2400" b="1">
+              <a:rPr sz="3000" b="1">
                 <a:solidFill>
                   <a:srgbClr val="1A1A1A"/>
                 </a:solidFill>
@@ -7472,7 +7142,7 @@
           <a:p>
             <a:pPr algn="l"/>
             <a:r>
-              <a:rPr sz="1300" b="0">
+              <a:rPr sz="1600" b="0">
                 <a:solidFill>
                   <a:srgbClr val="6B7280"/>
                 </a:solidFill>
@@ -7507,7 +7177,7 @@
           <a:p>
             <a:pPr algn="l"/>
             <a:r>
-              <a:rPr sz="1200" b="1">
+              <a:rPr sz="1100" b="1">
                 <a:solidFill>
                   <a:srgbClr val="E30613"/>
                 </a:solidFill>
@@ -7577,7 +7247,7 @@
           <a:p>
             <a:pPr algn="l"/>
             <a:r>
-              <a:rPr sz="1600" b="1">
+              <a:rPr sz="1400" b="1">
                 <a:solidFill>
                   <a:srgbClr val="E30613"/>
                 </a:solidFill>
@@ -7612,7 +7282,7 @@
           <a:p>
             <a:pPr algn="l"/>
             <a:r>
-              <a:rPr sz="1300" b="0">
+              <a:rPr sz="1400" b="0">
                 <a:solidFill>
                   <a:srgbClr val="1A1A1A"/>
                 </a:solidFill>
@@ -7647,7 +7317,7 @@
           <a:p>
             <a:pPr algn="l"/>
             <a:r>
-              <a:rPr sz="1600" b="1">
+              <a:rPr sz="1400" b="1">
                 <a:solidFill>
                   <a:srgbClr val="E30613"/>
                 </a:solidFill>
@@ -7682,7 +7352,7 @@
           <a:p>
             <a:pPr algn="l"/>
             <a:r>
-              <a:rPr sz="1300" b="0">
+              <a:rPr sz="1400" b="0">
                 <a:solidFill>
                   <a:srgbClr val="1A1A1A"/>
                 </a:solidFill>
@@ -7717,7 +7387,7 @@
           <a:p>
             <a:pPr algn="l"/>
             <a:r>
-              <a:rPr sz="1600" b="1">
+              <a:rPr sz="1400" b="1">
                 <a:solidFill>
                   <a:srgbClr val="E30613"/>
                 </a:solidFill>
@@ -7752,7 +7422,7 @@
           <a:p>
             <a:pPr algn="l"/>
             <a:r>
-              <a:rPr sz="1300" b="0">
+              <a:rPr sz="1400" b="0">
                 <a:solidFill>
                   <a:srgbClr val="1A1A1A"/>
                 </a:solidFill>
@@ -7787,7 +7457,7 @@
           <a:p>
             <a:pPr algn="l"/>
             <a:r>
-              <a:rPr sz="1600" b="1">
+              <a:rPr sz="1400" b="1">
                 <a:solidFill>
                   <a:srgbClr val="E30613"/>
                 </a:solidFill>
@@ -7822,7 +7492,7 @@
           <a:p>
             <a:pPr algn="l"/>
             <a:r>
-              <a:rPr sz="1300" b="0">
+              <a:rPr sz="1400" b="0">
                 <a:solidFill>
                   <a:srgbClr val="1A1A1A"/>
                 </a:solidFill>
@@ -7857,9 +7527,9 @@
           <a:p>
             <a:pPr algn="l"/>
             <a:r>
-              <a:rPr sz="900" b="0">
-                <a:solidFill>
-                  <a:srgbClr val="6B7280"/>
+              <a:rPr sz="1200" b="0">
+                <a:solidFill>
+                  <a:srgbClr val="1A1A1A"/>
                 </a:solidFill>
                 <a:latin typeface="Inter"/>
               </a:rPr>
@@ -8026,73 +7696,6 @@
           </a:p>
         </p:txBody>
       </p:sp>
-      <p:sp>
-        <p:nvSpPr>
-          <p:cNvPr id="21" name="Rectangle 20"/>
-          <p:cNvSpPr/>
-          <p:nvPr/>
-        </p:nvSpPr>
-        <p:spPr>
-          <a:xfrm>
-            <a:off x="0" y="0"/>
-            <a:ext cx="90000" cy="6858000"/>
-          </a:xfrm>
-          <a:prstGeom prst="rect">
-            <a:avLst/>
-          </a:prstGeom>
-          <a:solidFill>
-            <a:srgbClr val="E30613"/>
-          </a:solidFill>
-          <a:ln>
-            <a:noFill/>
-          </a:ln>
-        </p:spPr>
-        <p:style>
-          <a:lnRef idx="1">
-            <a:schemeClr val="accent1"/>
-          </a:lnRef>
-          <a:fillRef idx="3">
-            <a:schemeClr val="accent1"/>
-          </a:fillRef>
-          <a:effectRef idx="2">
-            <a:schemeClr val="accent1"/>
-          </a:effectRef>
-          <a:fontRef idx="minor">
-            <a:schemeClr val="lt1"/>
-          </a:fontRef>
-        </p:style>
-        <p:txBody>
-          <a:bodyPr rtlCol="0" anchor="ctr"/>
-          <a:lstStyle/>
-          <a:p>
-            <a:pPr algn="ctr"/>
-          </a:p>
-        </p:txBody>
-      </p:sp>
-      <p:pic>
-        <p:nvPicPr>
-          <p:cNvPr id="22" name="Picture 21" descr="mma.jpg"/>
-          <p:cNvPicPr>
-            <a:picLocks noChangeAspect="1"/>
-          </p:cNvPicPr>
-          <p:nvPr/>
-        </p:nvPicPr>
-        <p:blipFill>
-          <a:blip r:embed="rId2"/>
-          <a:stretch>
-            <a:fillRect/>
-          </a:stretch>
-        </p:blipFill>
-        <p:spPr>
-          <a:xfrm>
-            <a:off x="7200000" y="2200000"/>
-            <a:ext cx="4500000" cy="3600000"/>
-          </a:xfrm>
-          <a:prstGeom prst="rect">
-            <a:avLst/>
-          </a:prstGeom>
-        </p:spPr>
-      </p:pic>
     </p:spTree>
   </p:cSld>
   <p:clrMapOvr>
@@ -8214,7 +7817,7 @@
           <a:p>
             <a:pPr algn="l"/>
             <a:r>
-              <a:rPr sz="2400" b="1">
+              <a:rPr sz="3000" b="1">
                 <a:solidFill>
                   <a:srgbClr val="1A1A1A"/>
                 </a:solidFill>
@@ -8249,7 +7852,7 @@
           <a:p>
             <a:pPr algn="l"/>
             <a:r>
-              <a:rPr sz="1300" b="0">
+              <a:rPr sz="1600" b="0">
                 <a:solidFill>
                   <a:srgbClr val="6B7280"/>
                 </a:solidFill>
@@ -8284,7 +7887,7 @@
           <a:p>
             <a:pPr algn="l"/>
             <a:r>
-              <a:rPr sz="1200" b="1">
+              <a:rPr sz="1100" b="1">
                 <a:solidFill>
                   <a:srgbClr val="E30613"/>
                 </a:solidFill>
@@ -8354,7 +7957,7 @@
           <a:p>
             <a:pPr algn="l"/>
             <a:r>
-              <a:rPr sz="1600" b="1">
+              <a:rPr sz="1400" b="1">
                 <a:solidFill>
                   <a:srgbClr val="E30613"/>
                 </a:solidFill>
@@ -8389,7 +7992,7 @@
           <a:p>
             <a:pPr algn="l"/>
             <a:r>
-              <a:rPr sz="1300" b="0">
+              <a:rPr sz="1400" b="0">
                 <a:solidFill>
                   <a:srgbClr val="1A1A1A"/>
                 </a:solidFill>
@@ -8424,7 +8027,7 @@
           <a:p>
             <a:pPr algn="l"/>
             <a:r>
-              <a:rPr sz="1600" b="1">
+              <a:rPr sz="1400" b="1">
                 <a:solidFill>
                   <a:srgbClr val="E30613"/>
                 </a:solidFill>
@@ -8459,7 +8062,7 @@
           <a:p>
             <a:pPr algn="l"/>
             <a:r>
-              <a:rPr sz="1300" b="0">
+              <a:rPr sz="1400" b="0">
                 <a:solidFill>
                   <a:srgbClr val="1A1A1A"/>
                 </a:solidFill>
@@ -8494,7 +8097,7 @@
           <a:p>
             <a:pPr algn="l"/>
             <a:r>
-              <a:rPr sz="1600" b="1">
+              <a:rPr sz="1400" b="1">
                 <a:solidFill>
                   <a:srgbClr val="E30613"/>
                 </a:solidFill>
@@ -8529,7 +8132,7 @@
           <a:p>
             <a:pPr algn="l"/>
             <a:r>
-              <a:rPr sz="1300" b="0">
+              <a:rPr sz="1400" b="0">
                 <a:solidFill>
                   <a:srgbClr val="1A1A1A"/>
                 </a:solidFill>
@@ -8634,9 +8237,9 @@
           <a:p>
             <a:pPr algn="l"/>
             <a:r>
-              <a:rPr sz="900" b="0">
-                <a:solidFill>
-                  <a:srgbClr val="6B7280"/>
+              <a:rPr sz="1200" b="0">
+                <a:solidFill>
+                  <a:srgbClr val="1A1A1A"/>
                 </a:solidFill>
                 <a:latin typeface="Inter"/>
               </a:rPr>
@@ -8800,49 +8403,6 @@
               </a:rPr>
               <a:t>16 / 25</a:t>
             </a:r>
-          </a:p>
-        </p:txBody>
-      </p:sp>
-      <p:sp>
-        <p:nvSpPr>
-          <p:cNvPr id="21" name="Rectangle 20"/>
-          <p:cNvSpPr/>
-          <p:nvPr/>
-        </p:nvSpPr>
-        <p:spPr>
-          <a:xfrm>
-            <a:off x="0" y="0"/>
-            <a:ext cx="90000" cy="6858000"/>
-          </a:xfrm>
-          <a:prstGeom prst="rect">
-            <a:avLst/>
-          </a:prstGeom>
-          <a:solidFill>
-            <a:srgbClr val="E30613"/>
-          </a:solidFill>
-          <a:ln>
-            <a:noFill/>
-          </a:ln>
-        </p:spPr>
-        <p:style>
-          <a:lnRef idx="1">
-            <a:schemeClr val="accent1"/>
-          </a:lnRef>
-          <a:fillRef idx="3">
-            <a:schemeClr val="accent1"/>
-          </a:fillRef>
-          <a:effectRef idx="2">
-            <a:schemeClr val="accent1"/>
-          </a:effectRef>
-          <a:fontRef idx="minor">
-            <a:schemeClr val="lt1"/>
-          </a:fontRef>
-        </p:style>
-        <p:txBody>
-          <a:bodyPr rtlCol="0" anchor="ctr"/>
-          <a:lstStyle/>
-          <a:p>
-            <a:pPr algn="ctr"/>
           </a:p>
         </p:txBody>
       </p:sp>
@@ -8967,7 +8527,7 @@
           <a:p>
             <a:pPr algn="l"/>
             <a:r>
-              <a:rPr sz="2400" b="1">
+              <a:rPr sz="3000" b="1">
                 <a:solidFill>
                   <a:srgbClr val="1A1A1A"/>
                 </a:solidFill>
@@ -9002,7 +8562,7 @@
           <a:p>
             <a:pPr algn="l"/>
             <a:r>
-              <a:rPr sz="1300" b="0">
+              <a:rPr sz="1600" b="0">
                 <a:solidFill>
                   <a:srgbClr val="6B7280"/>
                 </a:solidFill>
@@ -9037,7 +8597,7 @@
           <a:p>
             <a:pPr algn="l"/>
             <a:r>
-              <a:rPr sz="1200" b="1">
+              <a:rPr sz="1100" b="1">
                 <a:solidFill>
                   <a:srgbClr val="E30613"/>
                 </a:solidFill>
@@ -9107,7 +8667,7 @@
           <a:p>
             <a:pPr algn="l"/>
             <a:r>
-              <a:rPr sz="1600" b="1">
+              <a:rPr sz="1400" b="1">
                 <a:solidFill>
                   <a:srgbClr val="E30613"/>
                 </a:solidFill>
@@ -9142,7 +8702,7 @@
           <a:p>
             <a:pPr algn="l"/>
             <a:r>
-              <a:rPr sz="1300" b="0">
+              <a:rPr sz="1400" b="0">
                 <a:solidFill>
                   <a:srgbClr val="1A1A1A"/>
                 </a:solidFill>
@@ -9177,7 +8737,7 @@
           <a:p>
             <a:pPr algn="l"/>
             <a:r>
-              <a:rPr sz="1600" b="1">
+              <a:rPr sz="1400" b="1">
                 <a:solidFill>
                   <a:srgbClr val="E30613"/>
                 </a:solidFill>
@@ -9212,7 +8772,7 @@
           <a:p>
             <a:pPr algn="l"/>
             <a:r>
-              <a:rPr sz="1300" b="0">
+              <a:rPr sz="1400" b="0">
                 <a:solidFill>
                   <a:srgbClr val="1A1A1A"/>
                 </a:solidFill>
@@ -9247,7 +8807,7 @@
           <a:p>
             <a:pPr algn="l"/>
             <a:r>
-              <a:rPr sz="1600" b="1">
+              <a:rPr sz="1400" b="1">
                 <a:solidFill>
                   <a:srgbClr val="E30613"/>
                 </a:solidFill>
@@ -9282,7 +8842,7 @@
           <a:p>
             <a:pPr algn="l"/>
             <a:r>
-              <a:rPr sz="1300" b="0">
+              <a:rPr sz="1400" b="0">
                 <a:solidFill>
                   <a:srgbClr val="1A1A1A"/>
                 </a:solidFill>
@@ -9317,7 +8877,7 @@
           <a:p>
             <a:pPr algn="l"/>
             <a:r>
-              <a:rPr sz="1600" b="1">
+              <a:rPr sz="1400" b="1">
                 <a:solidFill>
                   <a:srgbClr val="E30613"/>
                 </a:solidFill>
@@ -9352,7 +8912,7 @@
           <a:p>
             <a:pPr algn="l"/>
             <a:r>
-              <a:rPr sz="1300" b="0">
+              <a:rPr sz="1400" b="0">
                 <a:solidFill>
                   <a:srgbClr val="1A1A1A"/>
                 </a:solidFill>
@@ -9387,9 +8947,9 @@
           <a:p>
             <a:pPr algn="l"/>
             <a:r>
-              <a:rPr sz="900" b="0">
-                <a:solidFill>
-                  <a:srgbClr val="6B7280"/>
+              <a:rPr sz="1200" b="0">
+                <a:solidFill>
+                  <a:srgbClr val="1A1A1A"/>
                 </a:solidFill>
                 <a:latin typeface="Inter"/>
               </a:rPr>
@@ -9556,73 +9116,6 @@
           </a:p>
         </p:txBody>
       </p:sp>
-      <p:sp>
-        <p:nvSpPr>
-          <p:cNvPr id="21" name="Rectangle 20"/>
-          <p:cNvSpPr/>
-          <p:nvPr/>
-        </p:nvSpPr>
-        <p:spPr>
-          <a:xfrm>
-            <a:off x="0" y="0"/>
-            <a:ext cx="90000" cy="6858000"/>
-          </a:xfrm>
-          <a:prstGeom prst="rect">
-            <a:avLst/>
-          </a:prstGeom>
-          <a:solidFill>
-            <a:srgbClr val="E30613"/>
-          </a:solidFill>
-          <a:ln>
-            <a:noFill/>
-          </a:ln>
-        </p:spPr>
-        <p:style>
-          <a:lnRef idx="1">
-            <a:schemeClr val="accent1"/>
-          </a:lnRef>
-          <a:fillRef idx="3">
-            <a:schemeClr val="accent1"/>
-          </a:fillRef>
-          <a:effectRef idx="2">
-            <a:schemeClr val="accent1"/>
-          </a:effectRef>
-          <a:fontRef idx="minor">
-            <a:schemeClr val="lt1"/>
-          </a:fontRef>
-        </p:style>
-        <p:txBody>
-          <a:bodyPr rtlCol="0" anchor="ctr"/>
-          <a:lstStyle/>
-          <a:p>
-            <a:pPr algn="ctr"/>
-          </a:p>
-        </p:txBody>
-      </p:sp>
-      <p:pic>
-        <p:nvPicPr>
-          <p:cNvPr id="22" name="Picture 21" descr="electrodes.jpg"/>
-          <p:cNvPicPr>
-            <a:picLocks noChangeAspect="1"/>
-          </p:cNvPicPr>
-          <p:nvPr/>
-        </p:nvPicPr>
-        <p:blipFill>
-          <a:blip r:embed="rId2"/>
-          <a:stretch>
-            <a:fillRect/>
-          </a:stretch>
-        </p:blipFill>
-        <p:spPr>
-          <a:xfrm>
-            <a:off x="7200000" y="2200000"/>
-            <a:ext cx="4500000" cy="3600000"/>
-          </a:xfrm>
-          <a:prstGeom prst="rect">
-            <a:avLst/>
-          </a:prstGeom>
-        </p:spPr>
-      </p:pic>
     </p:spTree>
   </p:cSld>
   <p:clrMapOvr>
@@ -9744,7 +9237,7 @@
           <a:p>
             <a:pPr algn="l"/>
             <a:r>
-              <a:rPr sz="2400" b="1">
+              <a:rPr sz="3000" b="1">
                 <a:solidFill>
                   <a:srgbClr val="1A1A1A"/>
                 </a:solidFill>
@@ -9779,7 +9272,7 @@
           <a:p>
             <a:pPr algn="l"/>
             <a:r>
-              <a:rPr sz="1300" b="0">
+              <a:rPr sz="1600" b="0">
                 <a:solidFill>
                   <a:srgbClr val="6B7280"/>
                 </a:solidFill>
@@ -9814,7 +9307,7 @@
           <a:p>
             <a:pPr algn="l"/>
             <a:r>
-              <a:rPr sz="1200" b="1">
+              <a:rPr sz="1100" b="1">
                 <a:solidFill>
                   <a:srgbClr val="E30613"/>
                 </a:solidFill>
@@ -9884,7 +9377,7 @@
           <a:p>
             <a:pPr algn="l"/>
             <a:r>
-              <a:rPr sz="1600" b="1">
+              <a:rPr sz="1400" b="1">
                 <a:solidFill>
                   <a:srgbClr val="E30613"/>
                 </a:solidFill>
@@ -9919,7 +9412,7 @@
           <a:p>
             <a:pPr algn="l"/>
             <a:r>
-              <a:rPr sz="1300" b="0">
+              <a:rPr sz="1400" b="0">
                 <a:solidFill>
                   <a:srgbClr val="1A1A1A"/>
                 </a:solidFill>
@@ -9954,7 +9447,7 @@
           <a:p>
             <a:pPr algn="l"/>
             <a:r>
-              <a:rPr sz="1600" b="1">
+              <a:rPr sz="1400" b="1">
                 <a:solidFill>
                   <a:srgbClr val="E30613"/>
                 </a:solidFill>
@@ -9989,7 +9482,7 @@
           <a:p>
             <a:pPr algn="l"/>
             <a:r>
-              <a:rPr sz="1300" b="0">
+              <a:rPr sz="1400" b="0">
                 <a:solidFill>
                   <a:srgbClr val="1A1A1A"/>
                 </a:solidFill>
@@ -10164,9 +9657,9 @@
           <a:p>
             <a:pPr algn="l"/>
             <a:r>
-              <a:rPr sz="900" b="0">
-                <a:solidFill>
-                  <a:srgbClr val="6B7280"/>
+              <a:rPr sz="1200" b="0">
+                <a:solidFill>
+                  <a:srgbClr val="1A1A1A"/>
                 </a:solidFill>
                 <a:latin typeface="Inter"/>
               </a:rPr>
@@ -10330,49 +9823,6 @@
               </a:rPr>
               <a:t>18 / 25</a:t>
             </a:r>
-          </a:p>
-        </p:txBody>
-      </p:sp>
-      <p:sp>
-        <p:nvSpPr>
-          <p:cNvPr id="21" name="Rectangle 20"/>
-          <p:cNvSpPr/>
-          <p:nvPr/>
-        </p:nvSpPr>
-        <p:spPr>
-          <a:xfrm>
-            <a:off x="0" y="0"/>
-            <a:ext cx="90000" cy="6858000"/>
-          </a:xfrm>
-          <a:prstGeom prst="rect">
-            <a:avLst/>
-          </a:prstGeom>
-          <a:solidFill>
-            <a:srgbClr val="E30613"/>
-          </a:solidFill>
-          <a:ln>
-            <a:noFill/>
-          </a:ln>
-        </p:spPr>
-        <p:style>
-          <a:lnRef idx="1">
-            <a:schemeClr val="accent1"/>
-          </a:lnRef>
-          <a:fillRef idx="3">
-            <a:schemeClr val="accent1"/>
-          </a:fillRef>
-          <a:effectRef idx="2">
-            <a:schemeClr val="accent1"/>
-          </a:effectRef>
-          <a:fontRef idx="minor">
-            <a:schemeClr val="lt1"/>
-          </a:fontRef>
-        </p:style>
-        <p:txBody>
-          <a:bodyPr rtlCol="0" anchor="ctr"/>
-          <a:lstStyle/>
-          <a:p>
-            <a:pPr algn="ctr"/>
           </a:p>
         </p:txBody>
       </p:sp>
@@ -10497,7 +9947,7 @@
           <a:p>
             <a:pPr algn="l"/>
             <a:r>
-              <a:rPr sz="2400" b="1">
+              <a:rPr sz="3000" b="1">
                 <a:solidFill>
                   <a:srgbClr val="1A1A1A"/>
                 </a:solidFill>
@@ -10532,7 +9982,7 @@
           <a:p>
             <a:pPr algn="l"/>
             <a:r>
-              <a:rPr sz="1300" b="0">
+              <a:rPr sz="1600" b="0">
                 <a:solidFill>
                   <a:srgbClr val="6B7280"/>
                 </a:solidFill>
@@ -10567,7 +10017,7 @@
           <a:p>
             <a:pPr algn="l"/>
             <a:r>
-              <a:rPr sz="1200" b="1">
+              <a:rPr sz="1100" b="1">
                 <a:solidFill>
                   <a:srgbClr val="E30613"/>
                 </a:solidFill>
@@ -10637,7 +10087,7 @@
           <a:p>
             <a:pPr algn="l"/>
             <a:r>
-              <a:rPr sz="1600" b="1">
+              <a:rPr sz="1400" b="1">
                 <a:solidFill>
                   <a:srgbClr val="E30613"/>
                 </a:solidFill>
@@ -10672,7 +10122,7 @@
           <a:p>
             <a:pPr algn="l"/>
             <a:r>
-              <a:rPr sz="1300" b="0">
+              <a:rPr sz="1400" b="0">
                 <a:solidFill>
                   <a:srgbClr val="1A1A1A"/>
                 </a:solidFill>
@@ -10707,7 +10157,7 @@
           <a:p>
             <a:pPr algn="l"/>
             <a:r>
-              <a:rPr sz="1600" b="1">
+              <a:rPr sz="1400" b="1">
                 <a:solidFill>
                   <a:srgbClr val="E30613"/>
                 </a:solidFill>
@@ -10742,7 +10192,7 @@
           <a:p>
             <a:pPr algn="l"/>
             <a:r>
-              <a:rPr sz="1300" b="0">
+              <a:rPr sz="1400" b="0">
                 <a:solidFill>
                   <a:srgbClr val="1A1A1A"/>
                 </a:solidFill>
@@ -10777,7 +10227,7 @@
           <a:p>
             <a:pPr algn="l"/>
             <a:r>
-              <a:rPr sz="1600" b="1">
+              <a:rPr sz="1400" b="1">
                 <a:solidFill>
                   <a:srgbClr val="E30613"/>
                 </a:solidFill>
@@ -10812,7 +10262,7 @@
           <a:p>
             <a:pPr algn="l"/>
             <a:r>
-              <a:rPr sz="1300" b="0">
+              <a:rPr sz="1400" b="0">
                 <a:solidFill>
                   <a:srgbClr val="1A1A1A"/>
                 </a:solidFill>
@@ -10847,7 +10297,7 @@
           <a:p>
             <a:pPr algn="l"/>
             <a:r>
-              <a:rPr sz="1600" b="1">
+              <a:rPr sz="1400" b="1">
                 <a:solidFill>
                   <a:srgbClr val="E30613"/>
                 </a:solidFill>
@@ -10882,7 +10332,7 @@
           <a:p>
             <a:pPr algn="l"/>
             <a:r>
-              <a:rPr sz="1300" b="0">
+              <a:rPr sz="1400" b="0">
                 <a:solidFill>
                   <a:srgbClr val="1A1A1A"/>
                 </a:solidFill>
@@ -10917,9 +10367,9 @@
           <a:p>
             <a:pPr algn="l"/>
             <a:r>
-              <a:rPr sz="900" b="0">
-                <a:solidFill>
-                  <a:srgbClr val="6B7280"/>
+              <a:rPr sz="1200" b="0">
+                <a:solidFill>
+                  <a:srgbClr val="1A1A1A"/>
                 </a:solidFill>
                 <a:latin typeface="Inter"/>
               </a:rPr>
@@ -11083,49 +10533,6 @@
               </a:rPr>
               <a:t>19 / 25</a:t>
             </a:r>
-          </a:p>
-        </p:txBody>
-      </p:sp>
-      <p:sp>
-        <p:nvSpPr>
-          <p:cNvPr id="21" name="Rectangle 20"/>
-          <p:cNvSpPr/>
-          <p:nvPr/>
-        </p:nvSpPr>
-        <p:spPr>
-          <a:xfrm>
-            <a:off x="0" y="0"/>
-            <a:ext cx="90000" cy="6858000"/>
-          </a:xfrm>
-          <a:prstGeom prst="rect">
-            <a:avLst/>
-          </a:prstGeom>
-          <a:solidFill>
-            <a:srgbClr val="E30613"/>
-          </a:solidFill>
-          <a:ln>
-            <a:noFill/>
-          </a:ln>
-        </p:spPr>
-        <p:style>
-          <a:lnRef idx="1">
-            <a:schemeClr val="accent1"/>
-          </a:lnRef>
-          <a:fillRef idx="3">
-            <a:schemeClr val="accent1"/>
-          </a:fillRef>
-          <a:effectRef idx="2">
-            <a:schemeClr val="accent1"/>
-          </a:effectRef>
-          <a:fontRef idx="minor">
-            <a:schemeClr val="lt1"/>
-          </a:fontRef>
-        </p:style>
-        <p:txBody>
-          <a:bodyPr rtlCol="0" anchor="ctr"/>
-          <a:lstStyle/>
-          <a:p>
-            <a:pPr algn="ctr"/>
           </a:p>
         </p:txBody>
       </p:sp>
@@ -11250,7 +10657,7 @@
           <a:p>
             <a:pPr algn="l"/>
             <a:r>
-              <a:rPr sz="2400" b="1">
+              <a:rPr sz="3000" b="1">
                 <a:solidFill>
                   <a:srgbClr val="1A1A1A"/>
                 </a:solidFill>
@@ -11285,7 +10692,7 @@
           <a:p>
             <a:pPr algn="l"/>
             <a:r>
-              <a:rPr sz="1300" b="0">
+              <a:rPr sz="1600" b="0">
                 <a:solidFill>
                   <a:srgbClr val="6B7280"/>
                 </a:solidFill>
@@ -11320,7 +10727,7 @@
           <a:p>
             <a:pPr algn="l"/>
             <a:r>
-              <a:rPr sz="1200" b="1">
+              <a:rPr sz="1100" b="1">
                 <a:solidFill>
                   <a:srgbClr val="E30613"/>
                 </a:solidFill>
@@ -11390,7 +10797,7 @@
           <a:p>
             <a:pPr algn="l"/>
             <a:r>
-              <a:rPr sz="1600" b="1">
+              <a:rPr sz="1400" b="1">
                 <a:solidFill>
                   <a:srgbClr val="E30613"/>
                 </a:solidFill>
@@ -11425,7 +10832,7 @@
           <a:p>
             <a:pPr algn="l"/>
             <a:r>
-              <a:rPr sz="1300" b="0">
+              <a:rPr sz="1400" b="0">
                 <a:solidFill>
                   <a:srgbClr val="1A1A1A"/>
                 </a:solidFill>
@@ -11460,7 +10867,7 @@
           <a:p>
             <a:pPr algn="l"/>
             <a:r>
-              <a:rPr sz="1600" b="1">
+              <a:rPr sz="1400" b="1">
                 <a:solidFill>
                   <a:srgbClr val="E30613"/>
                 </a:solidFill>
@@ -11495,7 +10902,7 @@
           <a:p>
             <a:pPr algn="l"/>
             <a:r>
-              <a:rPr sz="1300" b="0">
+              <a:rPr sz="1400" b="0">
                 <a:solidFill>
                   <a:srgbClr val="1A1A1A"/>
                 </a:solidFill>
@@ -11530,7 +10937,7 @@
           <a:p>
             <a:pPr algn="l"/>
             <a:r>
-              <a:rPr sz="1600" b="1">
+              <a:rPr sz="1400" b="1">
                 <a:solidFill>
                   <a:srgbClr val="E30613"/>
                 </a:solidFill>
@@ -11565,7 +10972,7 @@
           <a:p>
             <a:pPr algn="l"/>
             <a:r>
-              <a:rPr sz="1300" b="0">
+              <a:rPr sz="1400" b="0">
                 <a:solidFill>
                   <a:srgbClr val="1A1A1A"/>
                 </a:solidFill>
@@ -11600,7 +11007,7 @@
           <a:p>
             <a:pPr algn="l"/>
             <a:r>
-              <a:rPr sz="1600" b="1">
+              <a:rPr sz="1400" b="1">
                 <a:solidFill>
                   <a:srgbClr val="E30613"/>
                 </a:solidFill>
@@ -11635,7 +11042,7 @@
           <a:p>
             <a:pPr algn="l"/>
             <a:r>
-              <a:rPr sz="1300" b="0">
+              <a:rPr sz="1400" b="0">
                 <a:solidFill>
                   <a:srgbClr val="1A1A1A"/>
                 </a:solidFill>
@@ -11670,9 +11077,9 @@
           <a:p>
             <a:pPr algn="l"/>
             <a:r>
-              <a:rPr sz="900" b="0">
-                <a:solidFill>
-                  <a:srgbClr val="6B7280"/>
+              <a:rPr sz="1200" b="0">
+                <a:solidFill>
+                  <a:srgbClr val="1A1A1A"/>
                 </a:solidFill>
                 <a:latin typeface="Inter"/>
               </a:rPr>
@@ -11836,49 +11243,6 @@
               </a:rPr>
               <a:t>02 / 25</a:t>
             </a:r>
-          </a:p>
-        </p:txBody>
-      </p:sp>
-      <p:sp>
-        <p:nvSpPr>
-          <p:cNvPr id="21" name="Rectangle 20"/>
-          <p:cNvSpPr/>
-          <p:nvPr/>
-        </p:nvSpPr>
-        <p:spPr>
-          <a:xfrm>
-            <a:off x="0" y="0"/>
-            <a:ext cx="90000" cy="6858000"/>
-          </a:xfrm>
-          <a:prstGeom prst="rect">
-            <a:avLst/>
-          </a:prstGeom>
-          <a:solidFill>
-            <a:srgbClr val="E30613"/>
-          </a:solidFill>
-          <a:ln>
-            <a:noFill/>
-          </a:ln>
-        </p:spPr>
-        <p:style>
-          <a:lnRef idx="1">
-            <a:schemeClr val="accent1"/>
-          </a:lnRef>
-          <a:fillRef idx="3">
-            <a:schemeClr val="accent1"/>
-          </a:fillRef>
-          <a:effectRef idx="2">
-            <a:schemeClr val="accent1"/>
-          </a:effectRef>
-          <a:fontRef idx="minor">
-            <a:schemeClr val="lt1"/>
-          </a:fontRef>
-        </p:style>
-        <p:txBody>
-          <a:bodyPr rtlCol="0" anchor="ctr"/>
-          <a:lstStyle/>
-          <a:p>
-            <a:pPr algn="ctr"/>
           </a:p>
         </p:txBody>
       </p:sp>
@@ -12003,7 +11367,7 @@
           <a:p>
             <a:pPr algn="l"/>
             <a:r>
-              <a:rPr sz="2400" b="1">
+              <a:rPr sz="3000" b="1">
                 <a:solidFill>
                   <a:srgbClr val="1A1A1A"/>
                 </a:solidFill>
@@ -12038,7 +11402,7 @@
           <a:p>
             <a:pPr algn="l"/>
             <a:r>
-              <a:rPr sz="1300" b="0">
+              <a:rPr sz="1600" b="0">
                 <a:solidFill>
                   <a:srgbClr val="6B7280"/>
                 </a:solidFill>
@@ -12073,7 +11437,7 @@
           <a:p>
             <a:pPr algn="l"/>
             <a:r>
-              <a:rPr sz="1200" b="1">
+              <a:rPr sz="1100" b="1">
                 <a:solidFill>
                   <a:srgbClr val="E30613"/>
                 </a:solidFill>
@@ -12143,7 +11507,7 @@
           <a:p>
             <a:pPr algn="l"/>
             <a:r>
-              <a:rPr sz="1600" b="1">
+              <a:rPr sz="1400" b="1">
                 <a:solidFill>
                   <a:srgbClr val="E30613"/>
                 </a:solidFill>
@@ -12178,7 +11542,7 @@
           <a:p>
             <a:pPr algn="l"/>
             <a:r>
-              <a:rPr sz="1300" b="0">
+              <a:rPr sz="1400" b="0">
                 <a:solidFill>
                   <a:srgbClr val="1A1A1A"/>
                 </a:solidFill>
@@ -12213,7 +11577,7 @@
           <a:p>
             <a:pPr algn="l"/>
             <a:r>
-              <a:rPr sz="1600" b="1">
+              <a:rPr sz="1400" b="1">
                 <a:solidFill>
                   <a:srgbClr val="E30613"/>
                 </a:solidFill>
@@ -12248,7 +11612,7 @@
           <a:p>
             <a:pPr algn="l"/>
             <a:r>
-              <a:rPr sz="1300" b="0">
+              <a:rPr sz="1400" b="0">
                 <a:solidFill>
                   <a:srgbClr val="1A1A1A"/>
                 </a:solidFill>
@@ -12283,7 +11647,7 @@
           <a:p>
             <a:pPr algn="l"/>
             <a:r>
-              <a:rPr sz="1600" b="1">
+              <a:rPr sz="1400" b="1">
                 <a:solidFill>
                   <a:srgbClr val="E30613"/>
                 </a:solidFill>
@@ -12318,7 +11682,7 @@
           <a:p>
             <a:pPr algn="l"/>
             <a:r>
-              <a:rPr sz="1300" b="0">
+              <a:rPr sz="1400" b="0">
                 <a:solidFill>
                   <a:srgbClr val="1A1A1A"/>
                 </a:solidFill>
@@ -12353,7 +11717,7 @@
           <a:p>
             <a:pPr algn="l"/>
             <a:r>
-              <a:rPr sz="1600" b="1">
+              <a:rPr sz="1400" b="1">
                 <a:solidFill>
                   <a:srgbClr val="E30613"/>
                 </a:solidFill>
@@ -12388,7 +11752,7 @@
           <a:p>
             <a:pPr algn="l"/>
             <a:r>
-              <a:rPr sz="1300" b="0">
+              <a:rPr sz="1400" b="0">
                 <a:solidFill>
                   <a:srgbClr val="1A1A1A"/>
                 </a:solidFill>
@@ -12423,9 +11787,9 @@
           <a:p>
             <a:pPr algn="l"/>
             <a:r>
-              <a:rPr sz="900" b="0">
-                <a:solidFill>
-                  <a:srgbClr val="6B7280"/>
+              <a:rPr sz="1200" b="0">
+                <a:solidFill>
+                  <a:srgbClr val="1A1A1A"/>
                 </a:solidFill>
                 <a:latin typeface="Inter"/>
               </a:rPr>
@@ -12589,49 +11953,6 @@
               </a:rPr>
               <a:t>20 / 25</a:t>
             </a:r>
-          </a:p>
-        </p:txBody>
-      </p:sp>
-      <p:sp>
-        <p:nvSpPr>
-          <p:cNvPr id="21" name="Rectangle 20"/>
-          <p:cNvSpPr/>
-          <p:nvPr/>
-        </p:nvSpPr>
-        <p:spPr>
-          <a:xfrm>
-            <a:off x="0" y="0"/>
-            <a:ext cx="90000" cy="6858000"/>
-          </a:xfrm>
-          <a:prstGeom prst="rect">
-            <a:avLst/>
-          </a:prstGeom>
-          <a:solidFill>
-            <a:srgbClr val="E30613"/>
-          </a:solidFill>
-          <a:ln>
-            <a:noFill/>
-          </a:ln>
-        </p:spPr>
-        <p:style>
-          <a:lnRef idx="1">
-            <a:schemeClr val="accent1"/>
-          </a:lnRef>
-          <a:fillRef idx="3">
-            <a:schemeClr val="accent1"/>
-          </a:fillRef>
-          <a:effectRef idx="2">
-            <a:schemeClr val="accent1"/>
-          </a:effectRef>
-          <a:fontRef idx="minor">
-            <a:schemeClr val="lt1"/>
-          </a:fontRef>
-        </p:style>
-        <p:txBody>
-          <a:bodyPr rtlCol="0" anchor="ctr"/>
-          <a:lstStyle/>
-          <a:p>
-            <a:pPr algn="ctr"/>
           </a:p>
         </p:txBody>
       </p:sp>
@@ -12756,7 +12077,7 @@
           <a:p>
             <a:pPr algn="l"/>
             <a:r>
-              <a:rPr sz="2400" b="1">
+              <a:rPr sz="3000" b="1">
                 <a:solidFill>
                   <a:srgbClr val="1A1A1A"/>
                 </a:solidFill>
@@ -12791,7 +12112,7 @@
           <a:p>
             <a:pPr algn="l"/>
             <a:r>
-              <a:rPr sz="1300" b="0">
+              <a:rPr sz="1600" b="0">
                 <a:solidFill>
                   <a:srgbClr val="6B7280"/>
                 </a:solidFill>
@@ -12826,7 +12147,7 @@
           <a:p>
             <a:pPr algn="l"/>
             <a:r>
-              <a:rPr sz="1200" b="1">
+              <a:rPr sz="1100" b="1">
                 <a:solidFill>
                   <a:srgbClr val="E30613"/>
                 </a:solidFill>
@@ -12896,7 +12217,7 @@
           <a:p>
             <a:pPr algn="l"/>
             <a:r>
-              <a:rPr sz="1600" b="1">
+              <a:rPr sz="1400" b="1">
                 <a:solidFill>
                   <a:srgbClr val="E30613"/>
                 </a:solidFill>
@@ -12931,7 +12252,7 @@
           <a:p>
             <a:pPr algn="l"/>
             <a:r>
-              <a:rPr sz="1300" b="0">
+              <a:rPr sz="1400" b="0">
                 <a:solidFill>
                   <a:srgbClr val="1A1A1A"/>
                 </a:solidFill>
@@ -13176,9 +12497,9 @@
           <a:p>
             <a:pPr algn="l"/>
             <a:r>
-              <a:rPr sz="900" b="0">
-                <a:solidFill>
-                  <a:srgbClr val="6B7280"/>
+              <a:rPr sz="1200" b="0">
+                <a:solidFill>
+                  <a:srgbClr val="1A1A1A"/>
                 </a:solidFill>
                 <a:latin typeface="Inter"/>
               </a:rPr>
@@ -13342,49 +12663,6 @@
               </a:rPr>
               <a:t>21 / 25</a:t>
             </a:r>
-          </a:p>
-        </p:txBody>
-      </p:sp>
-      <p:sp>
-        <p:nvSpPr>
-          <p:cNvPr id="21" name="Rectangle 20"/>
-          <p:cNvSpPr/>
-          <p:nvPr/>
-        </p:nvSpPr>
-        <p:spPr>
-          <a:xfrm>
-            <a:off x="0" y="0"/>
-            <a:ext cx="90000" cy="6858000"/>
-          </a:xfrm>
-          <a:prstGeom prst="rect">
-            <a:avLst/>
-          </a:prstGeom>
-          <a:solidFill>
-            <a:srgbClr val="E30613"/>
-          </a:solidFill>
-          <a:ln>
-            <a:noFill/>
-          </a:ln>
-        </p:spPr>
-        <p:style>
-          <a:lnRef idx="1">
-            <a:schemeClr val="accent1"/>
-          </a:lnRef>
-          <a:fillRef idx="3">
-            <a:schemeClr val="accent1"/>
-          </a:fillRef>
-          <a:effectRef idx="2">
-            <a:schemeClr val="accent1"/>
-          </a:effectRef>
-          <a:fontRef idx="minor">
-            <a:schemeClr val="lt1"/>
-          </a:fontRef>
-        </p:style>
-        <p:txBody>
-          <a:bodyPr rtlCol="0" anchor="ctr"/>
-          <a:lstStyle/>
-          <a:p>
-            <a:pPr algn="ctr"/>
           </a:p>
         </p:txBody>
       </p:sp>
@@ -13509,7 +12787,7 @@
           <a:p>
             <a:pPr algn="l"/>
             <a:r>
-              <a:rPr sz="2400" b="1">
+              <a:rPr sz="3000" b="1">
                 <a:solidFill>
                   <a:srgbClr val="1A1A1A"/>
                 </a:solidFill>
@@ -13544,7 +12822,7 @@
           <a:p>
             <a:pPr algn="l"/>
             <a:r>
-              <a:rPr sz="1300" b="0">
+              <a:rPr sz="1600" b="0">
                 <a:solidFill>
                   <a:srgbClr val="6B7280"/>
                 </a:solidFill>
@@ -13579,7 +12857,7 @@
           <a:p>
             <a:pPr algn="l"/>
             <a:r>
-              <a:rPr sz="1200" b="1">
+              <a:rPr sz="1100" b="1">
                 <a:solidFill>
                   <a:srgbClr val="E30613"/>
                 </a:solidFill>
@@ -13649,7 +12927,7 @@
           <a:p>
             <a:pPr algn="l"/>
             <a:r>
-              <a:rPr sz="1600" b="1">
+              <a:rPr sz="1400" b="1">
                 <a:solidFill>
                   <a:srgbClr val="E30613"/>
                 </a:solidFill>
@@ -13684,7 +12962,7 @@
           <a:p>
             <a:pPr algn="l"/>
             <a:r>
-              <a:rPr sz="1300" b="0">
+              <a:rPr sz="1400" b="0">
                 <a:solidFill>
                   <a:srgbClr val="1A1A1A"/>
                 </a:solidFill>
@@ -13719,7 +12997,7 @@
           <a:p>
             <a:pPr algn="l"/>
             <a:r>
-              <a:rPr sz="1600" b="1">
+              <a:rPr sz="1400" b="1">
                 <a:solidFill>
                   <a:srgbClr val="E30613"/>
                 </a:solidFill>
@@ -13754,7 +13032,7 @@
           <a:p>
             <a:pPr algn="l"/>
             <a:r>
-              <a:rPr sz="1300" b="0">
+              <a:rPr sz="1400" b="0">
                 <a:solidFill>
                   <a:srgbClr val="1A1A1A"/>
                 </a:solidFill>
@@ -13789,7 +13067,7 @@
           <a:p>
             <a:pPr algn="l"/>
             <a:r>
-              <a:rPr sz="1600" b="1">
+              <a:rPr sz="1400" b="1">
                 <a:solidFill>
                   <a:srgbClr val="E30613"/>
                 </a:solidFill>
@@ -13824,7 +13102,7 @@
           <a:p>
             <a:pPr algn="l"/>
             <a:r>
-              <a:rPr sz="1300" b="0">
+              <a:rPr sz="1400" b="0">
                 <a:solidFill>
                   <a:srgbClr val="1A1A1A"/>
                 </a:solidFill>
@@ -13859,7 +13137,7 @@
           <a:p>
             <a:pPr algn="l"/>
             <a:r>
-              <a:rPr sz="1600" b="1">
+              <a:rPr sz="1400" b="1">
                 <a:solidFill>
                   <a:srgbClr val="E30613"/>
                 </a:solidFill>
@@ -13894,7 +13172,7 @@
           <a:p>
             <a:pPr algn="l"/>
             <a:r>
-              <a:rPr sz="1300" b="0">
+              <a:rPr sz="1400" b="0">
                 <a:solidFill>
                   <a:srgbClr val="1A1A1A"/>
                 </a:solidFill>
@@ -13929,9 +13207,9 @@
           <a:p>
             <a:pPr algn="l"/>
             <a:r>
-              <a:rPr sz="900" b="0">
-                <a:solidFill>
-                  <a:srgbClr val="6B7280"/>
+              <a:rPr sz="1200" b="0">
+                <a:solidFill>
+                  <a:srgbClr val="1A1A1A"/>
                 </a:solidFill>
                 <a:latin typeface="Inter"/>
               </a:rPr>
@@ -14098,73 +13376,6 @@
           </a:p>
         </p:txBody>
       </p:sp>
-      <p:sp>
-        <p:nvSpPr>
-          <p:cNvPr id="21" name="Rectangle 20"/>
-          <p:cNvSpPr/>
-          <p:nvPr/>
-        </p:nvSpPr>
-        <p:spPr>
-          <a:xfrm>
-            <a:off x="0" y="0"/>
-            <a:ext cx="90000" cy="6858000"/>
-          </a:xfrm>
-          <a:prstGeom prst="rect">
-            <a:avLst/>
-          </a:prstGeom>
-          <a:solidFill>
-            <a:srgbClr val="E30613"/>
-          </a:solidFill>
-          <a:ln>
-            <a:noFill/>
-          </a:ln>
-        </p:spPr>
-        <p:style>
-          <a:lnRef idx="1">
-            <a:schemeClr val="accent1"/>
-          </a:lnRef>
-          <a:fillRef idx="3">
-            <a:schemeClr val="accent1"/>
-          </a:fillRef>
-          <a:effectRef idx="2">
-            <a:schemeClr val="accent1"/>
-          </a:effectRef>
-          <a:fontRef idx="minor">
-            <a:schemeClr val="lt1"/>
-          </a:fontRef>
-        </p:style>
-        <p:txBody>
-          <a:bodyPr rtlCol="0" anchor="ctr"/>
-          <a:lstStyle/>
-          <a:p>
-            <a:pPr algn="ctr"/>
-          </a:p>
-        </p:txBody>
-      </p:sp>
-      <p:pic>
-        <p:nvPicPr>
-          <p:cNvPr id="22" name="Picture 21" descr="tig.jpg"/>
-          <p:cNvPicPr>
-            <a:picLocks noChangeAspect="1"/>
-          </p:cNvPicPr>
-          <p:nvPr/>
-        </p:nvPicPr>
-        <p:blipFill>
-          <a:blip r:embed="rId2"/>
-          <a:stretch>
-            <a:fillRect/>
-          </a:stretch>
-        </p:blipFill>
-        <p:spPr>
-          <a:xfrm>
-            <a:off x="7200000" y="2200000"/>
-            <a:ext cx="4500000" cy="3600000"/>
-          </a:xfrm>
-          <a:prstGeom prst="rect">
-            <a:avLst/>
-          </a:prstGeom>
-        </p:spPr>
-      </p:pic>
     </p:spTree>
   </p:cSld>
   <p:clrMapOvr>
@@ -14286,7 +13497,7 @@
           <a:p>
             <a:pPr algn="l"/>
             <a:r>
-              <a:rPr sz="2400" b="1">
+              <a:rPr sz="3000" b="1">
                 <a:solidFill>
                   <a:srgbClr val="1A1A1A"/>
                 </a:solidFill>
@@ -14321,7 +13532,7 @@
           <a:p>
             <a:pPr algn="l"/>
             <a:r>
-              <a:rPr sz="1300" b="0">
+              <a:rPr sz="1600" b="0">
                 <a:solidFill>
                   <a:srgbClr val="6B7280"/>
                 </a:solidFill>
@@ -14356,7 +13567,7 @@
           <a:p>
             <a:pPr algn="l"/>
             <a:r>
-              <a:rPr sz="1200" b="1">
+              <a:rPr sz="1100" b="1">
                 <a:solidFill>
                   <a:srgbClr val="E30613"/>
                 </a:solidFill>
@@ -14426,7 +13637,7 @@
           <a:p>
             <a:pPr algn="l"/>
             <a:r>
-              <a:rPr sz="1600" b="1">
+              <a:rPr sz="1400" b="1">
                 <a:solidFill>
                   <a:srgbClr val="E30613"/>
                 </a:solidFill>
@@ -14461,7 +13672,7 @@
           <a:p>
             <a:pPr algn="l"/>
             <a:r>
-              <a:rPr sz="1300" b="0">
+              <a:rPr sz="1400" b="0">
                 <a:solidFill>
                   <a:srgbClr val="1A1A1A"/>
                 </a:solidFill>
@@ -14496,7 +13707,7 @@
           <a:p>
             <a:pPr algn="l"/>
             <a:r>
-              <a:rPr sz="1600" b="1">
+              <a:rPr sz="1400" b="1">
                 <a:solidFill>
                   <a:srgbClr val="E30613"/>
                 </a:solidFill>
@@ -14531,7 +13742,7 @@
           <a:p>
             <a:pPr algn="l"/>
             <a:r>
-              <a:rPr sz="1300" b="0">
+              <a:rPr sz="1400" b="0">
                 <a:solidFill>
                   <a:srgbClr val="1A1A1A"/>
                 </a:solidFill>
@@ -14566,7 +13777,7 @@
           <a:p>
             <a:pPr algn="l"/>
             <a:r>
-              <a:rPr sz="1600" b="1">
+              <a:rPr sz="1400" b="1">
                 <a:solidFill>
                   <a:srgbClr val="E30613"/>
                 </a:solidFill>
@@ -14601,7 +13812,7 @@
           <a:p>
             <a:pPr algn="l"/>
             <a:r>
-              <a:rPr sz="1300" b="0">
+              <a:rPr sz="1400" b="0">
                 <a:solidFill>
                   <a:srgbClr val="1A1A1A"/>
                 </a:solidFill>
@@ -14636,7 +13847,7 @@
           <a:p>
             <a:pPr algn="l"/>
             <a:r>
-              <a:rPr sz="1600" b="1">
+              <a:rPr sz="1400" b="1">
                 <a:solidFill>
                   <a:srgbClr val="E30613"/>
                 </a:solidFill>
@@ -14671,7 +13882,7 @@
           <a:p>
             <a:pPr algn="l"/>
             <a:r>
-              <a:rPr sz="1300" b="0">
+              <a:rPr sz="1400" b="0">
                 <a:solidFill>
                   <a:srgbClr val="1A1A1A"/>
                 </a:solidFill>
@@ -14706,9 +13917,9 @@
           <a:p>
             <a:pPr algn="l"/>
             <a:r>
-              <a:rPr sz="900" b="0">
-                <a:solidFill>
-                  <a:srgbClr val="6B7280"/>
+              <a:rPr sz="1200" b="0">
+                <a:solidFill>
+                  <a:srgbClr val="1A1A1A"/>
                 </a:solidFill>
                 <a:latin typeface="Inter"/>
               </a:rPr>
@@ -14872,49 +14083,6 @@
               </a:rPr>
               <a:t>23 / 25</a:t>
             </a:r>
-          </a:p>
-        </p:txBody>
-      </p:sp>
-      <p:sp>
-        <p:nvSpPr>
-          <p:cNvPr id="21" name="Rectangle 20"/>
-          <p:cNvSpPr/>
-          <p:nvPr/>
-        </p:nvSpPr>
-        <p:spPr>
-          <a:xfrm>
-            <a:off x="0" y="0"/>
-            <a:ext cx="90000" cy="6858000"/>
-          </a:xfrm>
-          <a:prstGeom prst="rect">
-            <a:avLst/>
-          </a:prstGeom>
-          <a:solidFill>
-            <a:srgbClr val="E30613"/>
-          </a:solidFill>
-          <a:ln>
-            <a:noFill/>
-          </a:ln>
-        </p:spPr>
-        <p:style>
-          <a:lnRef idx="1">
-            <a:schemeClr val="accent1"/>
-          </a:lnRef>
-          <a:fillRef idx="3">
-            <a:schemeClr val="accent1"/>
-          </a:fillRef>
-          <a:effectRef idx="2">
-            <a:schemeClr val="accent1"/>
-          </a:effectRef>
-          <a:fontRef idx="minor">
-            <a:schemeClr val="lt1"/>
-          </a:fontRef>
-        </p:style>
-        <p:txBody>
-          <a:bodyPr rtlCol="0" anchor="ctr"/>
-          <a:lstStyle/>
-          <a:p>
-            <a:pPr algn="ctr"/>
           </a:p>
         </p:txBody>
       </p:sp>
@@ -15039,7 +14207,7 @@
           <a:p>
             <a:pPr algn="l"/>
             <a:r>
-              <a:rPr sz="2400" b="1">
+              <a:rPr sz="3000" b="1">
                 <a:solidFill>
                   <a:srgbClr val="1A1A1A"/>
                 </a:solidFill>
@@ -15074,7 +14242,7 @@
           <a:p>
             <a:pPr algn="l"/>
             <a:r>
-              <a:rPr sz="1300" b="0">
+              <a:rPr sz="1600" b="0">
                 <a:solidFill>
                   <a:srgbClr val="6B7280"/>
                 </a:solidFill>
@@ -15109,7 +14277,7 @@
           <a:p>
             <a:pPr algn="l"/>
             <a:r>
-              <a:rPr sz="1200" b="1">
+              <a:rPr sz="1100" b="1">
                 <a:solidFill>
                   <a:srgbClr val="E30613"/>
                 </a:solidFill>
@@ -15179,7 +14347,7 @@
           <a:p>
             <a:pPr algn="l"/>
             <a:r>
-              <a:rPr sz="1600" b="1">
+              <a:rPr sz="1400" b="1">
                 <a:solidFill>
                   <a:srgbClr val="E30613"/>
                 </a:solidFill>
@@ -15214,7 +14382,7 @@
           <a:p>
             <a:pPr algn="l"/>
             <a:r>
-              <a:rPr sz="1300" b="0">
+              <a:rPr sz="1400" b="0">
                 <a:solidFill>
                   <a:srgbClr val="1A1A1A"/>
                 </a:solidFill>
@@ -15249,7 +14417,7 @@
           <a:p>
             <a:pPr algn="l"/>
             <a:r>
-              <a:rPr sz="1600" b="1">
+              <a:rPr sz="1400" b="1">
                 <a:solidFill>
                   <a:srgbClr val="E30613"/>
                 </a:solidFill>
@@ -15284,7 +14452,7 @@
           <a:p>
             <a:pPr algn="l"/>
             <a:r>
-              <a:rPr sz="1300" b="0">
+              <a:rPr sz="1400" b="0">
                 <a:solidFill>
                   <a:srgbClr val="1A1A1A"/>
                 </a:solidFill>
@@ -15319,7 +14487,7 @@
           <a:p>
             <a:pPr algn="l"/>
             <a:r>
-              <a:rPr sz="1600" b="1">
+              <a:rPr sz="1400" b="1">
                 <a:solidFill>
                   <a:srgbClr val="E30613"/>
                 </a:solidFill>
@@ -15354,7 +14522,7 @@
           <a:p>
             <a:pPr algn="l"/>
             <a:r>
-              <a:rPr sz="1300" b="0">
+              <a:rPr sz="1400" b="0">
                 <a:solidFill>
                   <a:srgbClr val="1A1A1A"/>
                 </a:solidFill>
@@ -15389,7 +14557,7 @@
           <a:p>
             <a:pPr algn="l"/>
             <a:r>
-              <a:rPr sz="1600" b="1">
+              <a:rPr sz="1400" b="1">
                 <a:solidFill>
                   <a:srgbClr val="E30613"/>
                 </a:solidFill>
@@ -15424,7 +14592,7 @@
           <a:p>
             <a:pPr algn="l"/>
             <a:r>
-              <a:rPr sz="1300" b="0">
+              <a:rPr sz="1400" b="0">
                 <a:solidFill>
                   <a:srgbClr val="1A1A1A"/>
                 </a:solidFill>
@@ -15459,9 +14627,9 @@
           <a:p>
             <a:pPr algn="l"/>
             <a:r>
-              <a:rPr sz="900" b="0">
-                <a:solidFill>
-                  <a:srgbClr val="6B7280"/>
+              <a:rPr sz="1200" b="0">
+                <a:solidFill>
+                  <a:srgbClr val="1A1A1A"/>
                 </a:solidFill>
                 <a:latin typeface="Inter"/>
               </a:rPr>
@@ -15625,49 +14793,6 @@
               </a:rPr>
               <a:t>24 / 25</a:t>
             </a:r>
-          </a:p>
-        </p:txBody>
-      </p:sp>
-      <p:sp>
-        <p:nvSpPr>
-          <p:cNvPr id="21" name="Rectangle 20"/>
-          <p:cNvSpPr/>
-          <p:nvPr/>
-        </p:nvSpPr>
-        <p:spPr>
-          <a:xfrm>
-            <a:off x="0" y="0"/>
-            <a:ext cx="90000" cy="6858000"/>
-          </a:xfrm>
-          <a:prstGeom prst="rect">
-            <a:avLst/>
-          </a:prstGeom>
-          <a:solidFill>
-            <a:srgbClr val="E30613"/>
-          </a:solidFill>
-          <a:ln>
-            <a:noFill/>
-          </a:ln>
-        </p:spPr>
-        <p:style>
-          <a:lnRef idx="1">
-            <a:schemeClr val="accent1"/>
-          </a:lnRef>
-          <a:fillRef idx="3">
-            <a:schemeClr val="accent1"/>
-          </a:fillRef>
-          <a:effectRef idx="2">
-            <a:schemeClr val="accent1"/>
-          </a:effectRef>
-          <a:fontRef idx="minor">
-            <a:schemeClr val="lt1"/>
-          </a:fontRef>
-        </p:style>
-        <p:txBody>
-          <a:bodyPr rtlCol="0" anchor="ctr"/>
-          <a:lstStyle/>
-          <a:p>
-            <a:pPr algn="ctr"/>
           </a:p>
         </p:txBody>
       </p:sp>
@@ -15792,7 +14917,7 @@
           <a:p>
             <a:pPr algn="l"/>
             <a:r>
-              <a:rPr sz="2400" b="1">
+              <a:rPr sz="3000" b="1">
                 <a:solidFill>
                   <a:srgbClr val="1A1A1A"/>
                 </a:solidFill>
@@ -15827,7 +14952,7 @@
           <a:p>
             <a:pPr algn="l"/>
             <a:r>
-              <a:rPr sz="1300" b="0">
+              <a:rPr sz="1600" b="0">
                 <a:solidFill>
                   <a:srgbClr val="6B7280"/>
                 </a:solidFill>
@@ -15862,7 +14987,7 @@
           <a:p>
             <a:pPr algn="l"/>
             <a:r>
-              <a:rPr sz="1200" b="1">
+              <a:rPr sz="1100" b="1">
                 <a:solidFill>
                   <a:srgbClr val="E30613"/>
                 </a:solidFill>
@@ -15932,7 +15057,7 @@
           <a:p>
             <a:pPr algn="l"/>
             <a:r>
-              <a:rPr sz="1600" b="1">
+              <a:rPr sz="1400" b="1">
                 <a:solidFill>
                   <a:srgbClr val="E30613"/>
                 </a:solidFill>
@@ -15967,7 +15092,7 @@
           <a:p>
             <a:pPr algn="l"/>
             <a:r>
-              <a:rPr sz="1300" b="0">
+              <a:rPr sz="1400" b="0">
                 <a:solidFill>
                   <a:srgbClr val="1A1A1A"/>
                 </a:solidFill>
@@ -16002,7 +15127,7 @@
           <a:p>
             <a:pPr algn="l"/>
             <a:r>
-              <a:rPr sz="1600" b="1">
+              <a:rPr sz="1400" b="1">
                 <a:solidFill>
                   <a:srgbClr val="E30613"/>
                 </a:solidFill>
@@ -16037,7 +15162,7 @@
           <a:p>
             <a:pPr algn="l"/>
             <a:r>
-              <a:rPr sz="1300" b="0">
+              <a:rPr sz="1400" b="0">
                 <a:solidFill>
                   <a:srgbClr val="1A1A1A"/>
                 </a:solidFill>
@@ -16072,7 +15197,7 @@
           <a:p>
             <a:pPr algn="l"/>
             <a:r>
-              <a:rPr sz="1600" b="1">
+              <a:rPr sz="1400" b="1">
                 <a:solidFill>
                   <a:srgbClr val="E30613"/>
                 </a:solidFill>
@@ -16107,7 +15232,7 @@
           <a:p>
             <a:pPr algn="l"/>
             <a:r>
-              <a:rPr sz="1300" b="0">
+              <a:rPr sz="1400" b="0">
                 <a:solidFill>
                   <a:srgbClr val="1A1A1A"/>
                 </a:solidFill>
@@ -16142,7 +15267,7 @@
           <a:p>
             <a:pPr algn="l"/>
             <a:r>
-              <a:rPr sz="1600" b="1">
+              <a:rPr sz="1400" b="1">
                 <a:solidFill>
                   <a:srgbClr val="E30613"/>
                 </a:solidFill>
@@ -16177,7 +15302,7 @@
           <a:p>
             <a:pPr algn="l"/>
             <a:r>
-              <a:rPr sz="1300" b="0">
+              <a:rPr sz="1400" b="0">
                 <a:solidFill>
                   <a:srgbClr val="1A1A1A"/>
                 </a:solidFill>
@@ -16212,9 +15337,9 @@
           <a:p>
             <a:pPr algn="l"/>
             <a:r>
-              <a:rPr sz="900" b="0">
-                <a:solidFill>
-                  <a:srgbClr val="6B7280"/>
+              <a:rPr sz="1200" b="0">
+                <a:solidFill>
+                  <a:srgbClr val="1A1A1A"/>
                 </a:solidFill>
                 <a:latin typeface="Inter"/>
               </a:rPr>
@@ -16381,73 +15506,6 @@
           </a:p>
         </p:txBody>
       </p:sp>
-      <p:sp>
-        <p:nvSpPr>
-          <p:cNvPr id="21" name="Rectangle 20"/>
-          <p:cNvSpPr/>
-          <p:nvPr/>
-        </p:nvSpPr>
-        <p:spPr>
-          <a:xfrm>
-            <a:off x="0" y="0"/>
-            <a:ext cx="90000" cy="6858000"/>
-          </a:xfrm>
-          <a:prstGeom prst="rect">
-            <a:avLst/>
-          </a:prstGeom>
-          <a:solidFill>
-            <a:srgbClr val="E30613"/>
-          </a:solidFill>
-          <a:ln>
-            <a:noFill/>
-          </a:ln>
-        </p:spPr>
-        <p:style>
-          <a:lnRef idx="1">
-            <a:schemeClr val="accent1"/>
-          </a:lnRef>
-          <a:fillRef idx="3">
-            <a:schemeClr val="accent1"/>
-          </a:fillRef>
-          <a:effectRef idx="2">
-            <a:schemeClr val="accent1"/>
-          </a:effectRef>
-          <a:fontRef idx="minor">
-            <a:schemeClr val="lt1"/>
-          </a:fontRef>
-        </p:style>
-        <p:txBody>
-          <a:bodyPr rtlCol="0" anchor="ctr"/>
-          <a:lstStyle/>
-          <a:p>
-            <a:pPr algn="ctr"/>
-          </a:p>
-        </p:txBody>
-      </p:sp>
-      <p:pic>
-        <p:nvPicPr>
-          <p:cNvPr id="22" name="Picture 21" descr="mpi.jpg"/>
-          <p:cNvPicPr>
-            <a:picLocks noChangeAspect="1"/>
-          </p:cNvPicPr>
-          <p:nvPr/>
-        </p:nvPicPr>
-        <p:blipFill>
-          <a:blip r:embed="rId2"/>
-          <a:stretch>
-            <a:fillRect/>
-          </a:stretch>
-        </p:blipFill>
-        <p:spPr>
-          <a:xfrm>
-            <a:off x="7200000" y="2200000"/>
-            <a:ext cx="4500000" cy="3600000"/>
-          </a:xfrm>
-          <a:prstGeom prst="rect">
-            <a:avLst/>
-          </a:prstGeom>
-        </p:spPr>
-      </p:pic>
     </p:spTree>
   </p:cSld>
   <p:clrMapOvr>
@@ -16569,7 +15627,7 @@
           <a:p>
             <a:pPr algn="l"/>
             <a:r>
-              <a:rPr sz="2400" b="1">
+              <a:rPr sz="3000" b="1">
                 <a:solidFill>
                   <a:srgbClr val="1A1A1A"/>
                 </a:solidFill>
@@ -16604,7 +15662,7 @@
           <a:p>
             <a:pPr algn="l"/>
             <a:r>
-              <a:rPr sz="1300" b="0">
+              <a:rPr sz="1600" b="0">
                 <a:solidFill>
                   <a:srgbClr val="6B7280"/>
                 </a:solidFill>
@@ -16639,7 +15697,7 @@
           <a:p>
             <a:pPr algn="l"/>
             <a:r>
-              <a:rPr sz="1200" b="1">
+              <a:rPr sz="1100" b="1">
                 <a:solidFill>
                   <a:srgbClr val="E30613"/>
                 </a:solidFill>
@@ -16709,7 +15767,7 @@
           <a:p>
             <a:pPr algn="l"/>
             <a:r>
-              <a:rPr sz="1600" b="1">
+              <a:rPr sz="1400" b="1">
                 <a:solidFill>
                   <a:srgbClr val="E30613"/>
                 </a:solidFill>
@@ -16744,7 +15802,7 @@
           <a:p>
             <a:pPr algn="l"/>
             <a:r>
-              <a:rPr sz="1300" b="0">
+              <a:rPr sz="1400" b="0">
                 <a:solidFill>
                   <a:srgbClr val="1A1A1A"/>
                 </a:solidFill>
@@ -16779,7 +15837,7 @@
           <a:p>
             <a:pPr algn="l"/>
             <a:r>
-              <a:rPr sz="1600" b="1">
+              <a:rPr sz="1400" b="1">
                 <a:solidFill>
                   <a:srgbClr val="E30613"/>
                 </a:solidFill>
@@ -16814,7 +15872,7 @@
           <a:p>
             <a:pPr algn="l"/>
             <a:r>
-              <a:rPr sz="1300" b="0">
+              <a:rPr sz="1400" b="0">
                 <a:solidFill>
                   <a:srgbClr val="1A1A1A"/>
                 </a:solidFill>
@@ -16849,7 +15907,7 @@
           <a:p>
             <a:pPr algn="l"/>
             <a:r>
-              <a:rPr sz="1600" b="1">
+              <a:rPr sz="1400" b="1">
                 <a:solidFill>
                   <a:srgbClr val="E30613"/>
                 </a:solidFill>
@@ -16884,7 +15942,7 @@
           <a:p>
             <a:pPr algn="l"/>
             <a:r>
-              <a:rPr sz="1300" b="0">
+              <a:rPr sz="1400" b="0">
                 <a:solidFill>
                   <a:srgbClr val="1A1A1A"/>
                 </a:solidFill>
@@ -16919,7 +15977,7 @@
           <a:p>
             <a:pPr algn="l"/>
             <a:r>
-              <a:rPr sz="1600" b="1">
+              <a:rPr sz="1400" b="1">
                 <a:solidFill>
                   <a:srgbClr val="E30613"/>
                 </a:solidFill>
@@ -16954,7 +16012,7 @@
           <a:p>
             <a:pPr algn="l"/>
             <a:r>
-              <a:rPr sz="1300" b="0">
+              <a:rPr sz="1400" b="0">
                 <a:solidFill>
                   <a:srgbClr val="1A1A1A"/>
                 </a:solidFill>
@@ -16989,9 +16047,9 @@
           <a:p>
             <a:pPr algn="l"/>
             <a:r>
-              <a:rPr sz="900" b="0">
-                <a:solidFill>
-                  <a:srgbClr val="6B7280"/>
+              <a:rPr sz="1200" b="0">
+                <a:solidFill>
+                  <a:srgbClr val="1A1A1A"/>
                 </a:solidFill>
                 <a:latin typeface="Inter"/>
               </a:rPr>
@@ -17158,73 +16216,6 @@
           </a:p>
         </p:txBody>
       </p:sp>
-      <p:sp>
-        <p:nvSpPr>
-          <p:cNvPr id="21" name="Rectangle 20"/>
-          <p:cNvSpPr/>
-          <p:nvPr/>
-        </p:nvSpPr>
-        <p:spPr>
-          <a:xfrm>
-            <a:off x="0" y="0"/>
-            <a:ext cx="90000" cy="6858000"/>
-          </a:xfrm>
-          <a:prstGeom prst="rect">
-            <a:avLst/>
-          </a:prstGeom>
-          <a:solidFill>
-            <a:srgbClr val="E30613"/>
-          </a:solidFill>
-          <a:ln>
-            <a:noFill/>
-          </a:ln>
-        </p:spPr>
-        <p:style>
-          <a:lnRef idx="1">
-            <a:schemeClr val="accent1"/>
-          </a:lnRef>
-          <a:fillRef idx="3">
-            <a:schemeClr val="accent1"/>
-          </a:fillRef>
-          <a:effectRef idx="2">
-            <a:schemeClr val="accent1"/>
-          </a:effectRef>
-          <a:fontRef idx="minor">
-            <a:schemeClr val="lt1"/>
-          </a:fontRef>
-        </p:style>
-        <p:txBody>
-          <a:bodyPr rtlCol="0" anchor="ctr"/>
-          <a:lstStyle/>
-          <a:p>
-            <a:pPr algn="ctr"/>
-          </a:p>
-        </p:txBody>
-      </p:sp>
-      <p:pic>
-        <p:nvPicPr>
-          <p:cNvPr id="22" name="Picture 21" descr="ppe_weld.jpg"/>
-          <p:cNvPicPr>
-            <a:picLocks noChangeAspect="1"/>
-          </p:cNvPicPr>
-          <p:nvPr/>
-        </p:nvPicPr>
-        <p:blipFill>
-          <a:blip r:embed="rId2"/>
-          <a:stretch>
-            <a:fillRect/>
-          </a:stretch>
-        </p:blipFill>
-        <p:spPr>
-          <a:xfrm>
-            <a:off x="7200000" y="2200000"/>
-            <a:ext cx="4500000" cy="3600000"/>
-          </a:xfrm>
-          <a:prstGeom prst="rect">
-            <a:avLst/>
-          </a:prstGeom>
-        </p:spPr>
-      </p:pic>
     </p:spTree>
   </p:cSld>
   <p:clrMapOvr>
@@ -17346,7 +16337,7 @@
           <a:p>
             <a:pPr algn="l"/>
             <a:r>
-              <a:rPr sz="2400" b="1">
+              <a:rPr sz="3000" b="1">
                 <a:solidFill>
                   <a:srgbClr val="1A1A1A"/>
                 </a:solidFill>
@@ -17381,7 +16372,7 @@
           <a:p>
             <a:pPr algn="l"/>
             <a:r>
-              <a:rPr sz="1300" b="0">
+              <a:rPr sz="1600" b="0">
                 <a:solidFill>
                   <a:srgbClr val="6B7280"/>
                 </a:solidFill>
@@ -17416,7 +16407,7 @@
           <a:p>
             <a:pPr algn="l"/>
             <a:r>
-              <a:rPr sz="1200" b="1">
+              <a:rPr sz="1100" b="1">
                 <a:solidFill>
                   <a:srgbClr val="E30613"/>
                 </a:solidFill>
@@ -17486,7 +16477,7 @@
           <a:p>
             <a:pPr algn="l"/>
             <a:r>
-              <a:rPr sz="1600" b="1">
+              <a:rPr sz="1400" b="1">
                 <a:solidFill>
                   <a:srgbClr val="E30613"/>
                 </a:solidFill>
@@ -17521,7 +16512,7 @@
           <a:p>
             <a:pPr algn="l"/>
             <a:r>
-              <a:rPr sz="1300" b="0">
+              <a:rPr sz="1400" b="0">
                 <a:solidFill>
                   <a:srgbClr val="1A1A1A"/>
                 </a:solidFill>
@@ -17556,7 +16547,7 @@
           <a:p>
             <a:pPr algn="l"/>
             <a:r>
-              <a:rPr sz="1600" b="1">
+              <a:rPr sz="1400" b="1">
                 <a:solidFill>
                   <a:srgbClr val="E30613"/>
                 </a:solidFill>
@@ -17591,7 +16582,7 @@
           <a:p>
             <a:pPr algn="l"/>
             <a:r>
-              <a:rPr sz="1300" b="0">
+              <a:rPr sz="1400" b="0">
                 <a:solidFill>
                   <a:srgbClr val="1A1A1A"/>
                 </a:solidFill>
@@ -17626,7 +16617,7 @@
           <a:p>
             <a:pPr algn="l"/>
             <a:r>
-              <a:rPr sz="1600" b="1">
+              <a:rPr sz="1400" b="1">
                 <a:solidFill>
                   <a:srgbClr val="E30613"/>
                 </a:solidFill>
@@ -17661,7 +16652,7 @@
           <a:p>
             <a:pPr algn="l"/>
             <a:r>
-              <a:rPr sz="1300" b="0">
+              <a:rPr sz="1400" b="0">
                 <a:solidFill>
                   <a:srgbClr val="1A1A1A"/>
                 </a:solidFill>
@@ -17696,7 +16687,7 @@
           <a:p>
             <a:pPr algn="l"/>
             <a:r>
-              <a:rPr sz="1600" b="1">
+              <a:rPr sz="1400" b="1">
                 <a:solidFill>
                   <a:srgbClr val="E30613"/>
                 </a:solidFill>
@@ -17731,7 +16722,7 @@
           <a:p>
             <a:pPr algn="l"/>
             <a:r>
-              <a:rPr sz="1300" b="0">
+              <a:rPr sz="1400" b="0">
                 <a:solidFill>
                   <a:srgbClr val="1A1A1A"/>
                 </a:solidFill>
@@ -17766,9 +16757,9 @@
           <a:p>
             <a:pPr algn="l"/>
             <a:r>
-              <a:rPr sz="900" b="0">
-                <a:solidFill>
-                  <a:srgbClr val="6B7280"/>
+              <a:rPr sz="1200" b="0">
+                <a:solidFill>
+                  <a:srgbClr val="1A1A1A"/>
                 </a:solidFill>
                 <a:latin typeface="Inter"/>
               </a:rPr>
@@ -17932,49 +16923,6 @@
               </a:rPr>
               <a:t>04 / 25</a:t>
             </a:r>
-          </a:p>
-        </p:txBody>
-      </p:sp>
-      <p:sp>
-        <p:nvSpPr>
-          <p:cNvPr id="21" name="Rectangle 20"/>
-          <p:cNvSpPr/>
-          <p:nvPr/>
-        </p:nvSpPr>
-        <p:spPr>
-          <a:xfrm>
-            <a:off x="0" y="0"/>
-            <a:ext cx="90000" cy="6858000"/>
-          </a:xfrm>
-          <a:prstGeom prst="rect">
-            <a:avLst/>
-          </a:prstGeom>
-          <a:solidFill>
-            <a:srgbClr val="E30613"/>
-          </a:solidFill>
-          <a:ln>
-            <a:noFill/>
-          </a:ln>
-        </p:spPr>
-        <p:style>
-          <a:lnRef idx="1">
-            <a:schemeClr val="accent1"/>
-          </a:lnRef>
-          <a:fillRef idx="3">
-            <a:schemeClr val="accent1"/>
-          </a:fillRef>
-          <a:effectRef idx="2">
-            <a:schemeClr val="accent1"/>
-          </a:effectRef>
-          <a:fontRef idx="minor">
-            <a:schemeClr val="lt1"/>
-          </a:fontRef>
-        </p:style>
-        <p:txBody>
-          <a:bodyPr rtlCol="0" anchor="ctr"/>
-          <a:lstStyle/>
-          <a:p>
-            <a:pPr algn="ctr"/>
           </a:p>
         </p:txBody>
       </p:sp>
@@ -18099,7 +17047,7 @@
           <a:p>
             <a:pPr algn="l"/>
             <a:r>
-              <a:rPr sz="2400" b="1">
+              <a:rPr sz="3000" b="1">
                 <a:solidFill>
                   <a:srgbClr val="1A1A1A"/>
                 </a:solidFill>
@@ -18134,7 +17082,7 @@
           <a:p>
             <a:pPr algn="l"/>
             <a:r>
-              <a:rPr sz="1300" b="0">
+              <a:rPr sz="1600" b="0">
                 <a:solidFill>
                   <a:srgbClr val="6B7280"/>
                 </a:solidFill>
@@ -18169,7 +17117,7 @@
           <a:p>
             <a:pPr algn="l"/>
             <a:r>
-              <a:rPr sz="1200" b="1">
+              <a:rPr sz="1100" b="1">
                 <a:solidFill>
                   <a:srgbClr val="E30613"/>
                 </a:solidFill>
@@ -18239,7 +17187,7 @@
           <a:p>
             <a:pPr algn="l"/>
             <a:r>
-              <a:rPr sz="1600" b="1">
+              <a:rPr sz="1400" b="1">
                 <a:solidFill>
                   <a:srgbClr val="E30613"/>
                 </a:solidFill>
@@ -18274,7 +17222,7 @@
           <a:p>
             <a:pPr algn="l"/>
             <a:r>
-              <a:rPr sz="1300" b="0">
+              <a:rPr sz="1400" b="0">
                 <a:solidFill>
                   <a:srgbClr val="1A1A1A"/>
                 </a:solidFill>
@@ -18309,7 +17257,7 @@
           <a:p>
             <a:pPr algn="l"/>
             <a:r>
-              <a:rPr sz="1600" b="1">
+              <a:rPr sz="1400" b="1">
                 <a:solidFill>
                   <a:srgbClr val="E30613"/>
                 </a:solidFill>
@@ -18344,7 +17292,7 @@
           <a:p>
             <a:pPr algn="l"/>
             <a:r>
-              <a:rPr sz="1300" b="0">
+              <a:rPr sz="1400" b="0">
                 <a:solidFill>
                   <a:srgbClr val="1A1A1A"/>
                 </a:solidFill>
@@ -18379,7 +17327,7 @@
           <a:p>
             <a:pPr algn="l"/>
             <a:r>
-              <a:rPr sz="1600" b="1">
+              <a:rPr sz="1400" b="1">
                 <a:solidFill>
                   <a:srgbClr val="E30613"/>
                 </a:solidFill>
@@ -18414,7 +17362,7 @@
           <a:p>
             <a:pPr algn="l"/>
             <a:r>
-              <a:rPr sz="1300" b="0">
+              <a:rPr sz="1400" b="0">
                 <a:solidFill>
                   <a:srgbClr val="1A1A1A"/>
                 </a:solidFill>
@@ -18449,7 +17397,7 @@
           <a:p>
             <a:pPr algn="l"/>
             <a:r>
-              <a:rPr sz="1600" b="1">
+              <a:rPr sz="1400" b="1">
                 <a:solidFill>
                   <a:srgbClr val="E30613"/>
                 </a:solidFill>
@@ -18484,7 +17432,7 @@
           <a:p>
             <a:pPr algn="l"/>
             <a:r>
-              <a:rPr sz="1300" b="0">
+              <a:rPr sz="1400" b="0">
                 <a:solidFill>
                   <a:srgbClr val="1A1A1A"/>
                 </a:solidFill>
@@ -18519,9 +17467,9 @@
           <a:p>
             <a:pPr algn="l"/>
             <a:r>
-              <a:rPr sz="900" b="0">
-                <a:solidFill>
-                  <a:srgbClr val="6B7280"/>
+              <a:rPr sz="1200" b="0">
+                <a:solidFill>
+                  <a:srgbClr val="1A1A1A"/>
                 </a:solidFill>
                 <a:latin typeface="Inter"/>
               </a:rPr>
@@ -18685,49 +17633,6 @@
               </a:rPr>
               <a:t>05 / 25</a:t>
             </a:r>
-          </a:p>
-        </p:txBody>
-      </p:sp>
-      <p:sp>
-        <p:nvSpPr>
-          <p:cNvPr id="21" name="Rectangle 20"/>
-          <p:cNvSpPr/>
-          <p:nvPr/>
-        </p:nvSpPr>
-        <p:spPr>
-          <a:xfrm>
-            <a:off x="0" y="0"/>
-            <a:ext cx="90000" cy="6858000"/>
-          </a:xfrm>
-          <a:prstGeom prst="rect">
-            <a:avLst/>
-          </a:prstGeom>
-          <a:solidFill>
-            <a:srgbClr val="E30613"/>
-          </a:solidFill>
-          <a:ln>
-            <a:noFill/>
-          </a:ln>
-        </p:spPr>
-        <p:style>
-          <a:lnRef idx="1">
-            <a:schemeClr val="accent1"/>
-          </a:lnRef>
-          <a:fillRef idx="3">
-            <a:schemeClr val="accent1"/>
-          </a:fillRef>
-          <a:effectRef idx="2">
-            <a:schemeClr val="accent1"/>
-          </a:effectRef>
-          <a:fontRef idx="minor">
-            <a:schemeClr val="lt1"/>
-          </a:fontRef>
-        </p:style>
-        <p:txBody>
-          <a:bodyPr rtlCol="0" anchor="ctr"/>
-          <a:lstStyle/>
-          <a:p>
-            <a:pPr algn="ctr"/>
           </a:p>
         </p:txBody>
       </p:sp>
@@ -18852,7 +17757,7 @@
           <a:p>
             <a:pPr algn="l"/>
             <a:r>
-              <a:rPr sz="2400" b="1">
+              <a:rPr sz="3000" b="1">
                 <a:solidFill>
                   <a:srgbClr val="1A1A1A"/>
                 </a:solidFill>
@@ -18887,7 +17792,7 @@
           <a:p>
             <a:pPr algn="l"/>
             <a:r>
-              <a:rPr sz="1300" b="0">
+              <a:rPr sz="1600" b="0">
                 <a:solidFill>
                   <a:srgbClr val="6B7280"/>
                 </a:solidFill>
@@ -18922,7 +17827,7 @@
           <a:p>
             <a:pPr algn="l"/>
             <a:r>
-              <a:rPr sz="1200" b="1">
+              <a:rPr sz="1100" b="1">
                 <a:solidFill>
                   <a:srgbClr val="E30613"/>
                 </a:solidFill>
@@ -18992,7 +17897,7 @@
           <a:p>
             <a:pPr algn="l"/>
             <a:r>
-              <a:rPr sz="1600" b="1">
+              <a:rPr sz="1400" b="1">
                 <a:solidFill>
                   <a:srgbClr val="E30613"/>
                 </a:solidFill>
@@ -19027,7 +17932,7 @@
           <a:p>
             <a:pPr algn="l"/>
             <a:r>
-              <a:rPr sz="1300" b="0">
+              <a:rPr sz="1400" b="0">
                 <a:solidFill>
                   <a:srgbClr val="1A1A1A"/>
                 </a:solidFill>
@@ -19062,7 +17967,7 @@
           <a:p>
             <a:pPr algn="l"/>
             <a:r>
-              <a:rPr sz="1600" b="1">
+              <a:rPr sz="1400" b="1">
                 <a:solidFill>
                   <a:srgbClr val="E30613"/>
                 </a:solidFill>
@@ -19097,7 +18002,7 @@
           <a:p>
             <a:pPr algn="l"/>
             <a:r>
-              <a:rPr sz="1300" b="0">
+              <a:rPr sz="1400" b="0">
                 <a:solidFill>
                   <a:srgbClr val="1A1A1A"/>
                 </a:solidFill>
@@ -19132,7 +18037,7 @@
           <a:p>
             <a:pPr algn="l"/>
             <a:r>
-              <a:rPr sz="1600" b="1">
+              <a:rPr sz="1400" b="1">
                 <a:solidFill>
                   <a:srgbClr val="E30613"/>
                 </a:solidFill>
@@ -19167,7 +18072,7 @@
           <a:p>
             <a:pPr algn="l"/>
             <a:r>
-              <a:rPr sz="1300" b="0">
+              <a:rPr sz="1400" b="0">
                 <a:solidFill>
                   <a:srgbClr val="1A1A1A"/>
                 </a:solidFill>
@@ -19202,7 +18107,7 @@
           <a:p>
             <a:pPr algn="l"/>
             <a:r>
-              <a:rPr sz="1600" b="1">
+              <a:rPr sz="1400" b="1">
                 <a:solidFill>
                   <a:srgbClr val="E30613"/>
                 </a:solidFill>
@@ -19237,7 +18142,7 @@
           <a:p>
             <a:pPr algn="l"/>
             <a:r>
-              <a:rPr sz="1300" b="0">
+              <a:rPr sz="1400" b="0">
                 <a:solidFill>
                   <a:srgbClr val="1A1A1A"/>
                 </a:solidFill>
@@ -19272,9 +18177,9 @@
           <a:p>
             <a:pPr algn="l"/>
             <a:r>
-              <a:rPr sz="900" b="0">
-                <a:solidFill>
-                  <a:srgbClr val="6B7280"/>
+              <a:rPr sz="1200" b="0">
+                <a:solidFill>
+                  <a:srgbClr val="1A1A1A"/>
                 </a:solidFill>
                 <a:latin typeface="Inter"/>
               </a:rPr>
@@ -19438,49 +18343,6 @@
               </a:rPr>
               <a:t>06 / 25</a:t>
             </a:r>
-          </a:p>
-        </p:txBody>
-      </p:sp>
-      <p:sp>
-        <p:nvSpPr>
-          <p:cNvPr id="21" name="Rectangle 20"/>
-          <p:cNvSpPr/>
-          <p:nvPr/>
-        </p:nvSpPr>
-        <p:spPr>
-          <a:xfrm>
-            <a:off x="0" y="0"/>
-            <a:ext cx="90000" cy="6858000"/>
-          </a:xfrm>
-          <a:prstGeom prst="rect">
-            <a:avLst/>
-          </a:prstGeom>
-          <a:solidFill>
-            <a:srgbClr val="E30613"/>
-          </a:solidFill>
-          <a:ln>
-            <a:noFill/>
-          </a:ln>
-        </p:spPr>
-        <p:style>
-          <a:lnRef idx="1">
-            <a:schemeClr val="accent1"/>
-          </a:lnRef>
-          <a:fillRef idx="3">
-            <a:schemeClr val="accent1"/>
-          </a:fillRef>
-          <a:effectRef idx="2">
-            <a:schemeClr val="accent1"/>
-          </a:effectRef>
-          <a:fontRef idx="minor">
-            <a:schemeClr val="lt1"/>
-          </a:fontRef>
-        </p:style>
-        <p:txBody>
-          <a:bodyPr rtlCol="0" anchor="ctr"/>
-          <a:lstStyle/>
-          <a:p>
-            <a:pPr algn="ctr"/>
           </a:p>
         </p:txBody>
       </p:sp>
@@ -19605,7 +18467,7 @@
           <a:p>
             <a:pPr algn="l"/>
             <a:r>
-              <a:rPr sz="2400" b="1">
+              <a:rPr sz="3000" b="1">
                 <a:solidFill>
                   <a:srgbClr val="1A1A1A"/>
                 </a:solidFill>
@@ -19640,7 +18502,7 @@
           <a:p>
             <a:pPr algn="l"/>
             <a:r>
-              <a:rPr sz="1300" b="0">
+              <a:rPr sz="1600" b="0">
                 <a:solidFill>
                   <a:srgbClr val="6B7280"/>
                 </a:solidFill>
@@ -19675,7 +18537,7 @@
           <a:p>
             <a:pPr algn="l"/>
             <a:r>
-              <a:rPr sz="1200" b="1">
+              <a:rPr sz="1100" b="1">
                 <a:solidFill>
                   <a:srgbClr val="E30613"/>
                 </a:solidFill>
@@ -19745,7 +18607,7 @@
           <a:p>
             <a:pPr algn="l"/>
             <a:r>
-              <a:rPr sz="1600" b="1">
+              <a:rPr sz="1400" b="1">
                 <a:solidFill>
                   <a:srgbClr val="E30613"/>
                 </a:solidFill>
@@ -19780,7 +18642,7 @@
           <a:p>
             <a:pPr algn="l"/>
             <a:r>
-              <a:rPr sz="1300" b="0">
+              <a:rPr sz="1400" b="0">
                 <a:solidFill>
                   <a:srgbClr val="1A1A1A"/>
                 </a:solidFill>
@@ -19815,7 +18677,7 @@
           <a:p>
             <a:pPr algn="l"/>
             <a:r>
-              <a:rPr sz="1600" b="1">
+              <a:rPr sz="1400" b="1">
                 <a:solidFill>
                   <a:srgbClr val="E30613"/>
                 </a:solidFill>
@@ -19850,7 +18712,7 @@
           <a:p>
             <a:pPr algn="l"/>
             <a:r>
-              <a:rPr sz="1300" b="0">
+              <a:rPr sz="1400" b="0">
                 <a:solidFill>
                   <a:srgbClr val="1A1A1A"/>
                 </a:solidFill>
@@ -19885,7 +18747,7 @@
           <a:p>
             <a:pPr algn="l"/>
             <a:r>
-              <a:rPr sz="1600" b="1">
+              <a:rPr sz="1400" b="1">
                 <a:solidFill>
                   <a:srgbClr val="E30613"/>
                 </a:solidFill>
@@ -19920,7 +18782,7 @@
           <a:p>
             <a:pPr algn="l"/>
             <a:r>
-              <a:rPr sz="1300" b="0">
+              <a:rPr sz="1400" b="0">
                 <a:solidFill>
                   <a:srgbClr val="1A1A1A"/>
                 </a:solidFill>
@@ -19955,7 +18817,7 @@
           <a:p>
             <a:pPr algn="l"/>
             <a:r>
-              <a:rPr sz="1600" b="1">
+              <a:rPr sz="1400" b="1">
                 <a:solidFill>
                   <a:srgbClr val="E30613"/>
                 </a:solidFill>
@@ -19990,7 +18852,7 @@
           <a:p>
             <a:pPr algn="l"/>
             <a:r>
-              <a:rPr sz="1300" b="0">
+              <a:rPr sz="1400" b="0">
                 <a:solidFill>
                   <a:srgbClr val="1A1A1A"/>
                 </a:solidFill>
@@ -20025,9 +18887,9 @@
           <a:p>
             <a:pPr algn="l"/>
             <a:r>
-              <a:rPr sz="900" b="0">
-                <a:solidFill>
-                  <a:srgbClr val="6B7280"/>
+              <a:rPr sz="1200" b="0">
+                <a:solidFill>
+                  <a:srgbClr val="1A1A1A"/>
                 </a:solidFill>
                 <a:latin typeface="Inter"/>
               </a:rPr>
@@ -20191,49 +19053,6 @@
               </a:rPr>
               <a:t>07 / 25</a:t>
             </a:r>
-          </a:p>
-        </p:txBody>
-      </p:sp>
-      <p:sp>
-        <p:nvSpPr>
-          <p:cNvPr id="21" name="Rectangle 20"/>
-          <p:cNvSpPr/>
-          <p:nvPr/>
-        </p:nvSpPr>
-        <p:spPr>
-          <a:xfrm>
-            <a:off x="0" y="0"/>
-            <a:ext cx="90000" cy="6858000"/>
-          </a:xfrm>
-          <a:prstGeom prst="rect">
-            <a:avLst/>
-          </a:prstGeom>
-          <a:solidFill>
-            <a:srgbClr val="E30613"/>
-          </a:solidFill>
-          <a:ln>
-            <a:noFill/>
-          </a:ln>
-        </p:spPr>
-        <p:style>
-          <a:lnRef idx="1">
-            <a:schemeClr val="accent1"/>
-          </a:lnRef>
-          <a:fillRef idx="3">
-            <a:schemeClr val="accent1"/>
-          </a:fillRef>
-          <a:effectRef idx="2">
-            <a:schemeClr val="accent1"/>
-          </a:effectRef>
-          <a:fontRef idx="minor">
-            <a:schemeClr val="lt1"/>
-          </a:fontRef>
-        </p:style>
-        <p:txBody>
-          <a:bodyPr rtlCol="0" anchor="ctr"/>
-          <a:lstStyle/>
-          <a:p>
-            <a:pPr algn="ctr"/>
           </a:p>
         </p:txBody>
       </p:sp>
@@ -20358,7 +19177,7 @@
           <a:p>
             <a:pPr algn="l"/>
             <a:r>
-              <a:rPr sz="2400" b="1">
+              <a:rPr sz="3000" b="1">
                 <a:solidFill>
                   <a:srgbClr val="1A1A1A"/>
                 </a:solidFill>
@@ -20393,7 +19212,7 @@
           <a:p>
             <a:pPr algn="l"/>
             <a:r>
-              <a:rPr sz="1300" b="0">
+              <a:rPr sz="1600" b="0">
                 <a:solidFill>
                   <a:srgbClr val="6B7280"/>
                 </a:solidFill>
@@ -20428,7 +19247,7 @@
           <a:p>
             <a:pPr algn="l"/>
             <a:r>
-              <a:rPr sz="1200" b="1">
+              <a:rPr sz="1100" b="1">
                 <a:solidFill>
                   <a:srgbClr val="E30613"/>
                 </a:solidFill>
@@ -20498,7 +19317,7 @@
           <a:p>
             <a:pPr algn="l"/>
             <a:r>
-              <a:rPr sz="1600" b="1">
+              <a:rPr sz="1400" b="1">
                 <a:solidFill>
                   <a:srgbClr val="E30613"/>
                 </a:solidFill>
@@ -20533,7 +19352,7 @@
           <a:p>
             <a:pPr algn="l"/>
             <a:r>
-              <a:rPr sz="1300" b="0">
+              <a:rPr sz="1400" b="0">
                 <a:solidFill>
                   <a:srgbClr val="1A1A1A"/>
                 </a:solidFill>
@@ -20568,7 +19387,7 @@
           <a:p>
             <a:pPr algn="l"/>
             <a:r>
-              <a:rPr sz="1600" b="1">
+              <a:rPr sz="1400" b="1">
                 <a:solidFill>
                   <a:srgbClr val="E30613"/>
                 </a:solidFill>
@@ -20603,7 +19422,7 @@
           <a:p>
             <a:pPr algn="l"/>
             <a:r>
-              <a:rPr sz="1300" b="0">
+              <a:rPr sz="1400" b="0">
                 <a:solidFill>
                   <a:srgbClr val="1A1A1A"/>
                 </a:solidFill>
@@ -20638,7 +19457,7 @@
           <a:p>
             <a:pPr algn="l"/>
             <a:r>
-              <a:rPr sz="1600" b="1">
+              <a:rPr sz="1400" b="1">
                 <a:solidFill>
                   <a:srgbClr val="E30613"/>
                 </a:solidFill>
@@ -20673,7 +19492,7 @@
           <a:p>
             <a:pPr algn="l"/>
             <a:r>
-              <a:rPr sz="1300" b="0">
+              <a:rPr sz="1400" b="0">
                 <a:solidFill>
                   <a:srgbClr val="1A1A1A"/>
                 </a:solidFill>
@@ -20708,7 +19527,7 @@
           <a:p>
             <a:pPr algn="l"/>
             <a:r>
-              <a:rPr sz="1600" b="1">
+              <a:rPr sz="1400" b="1">
                 <a:solidFill>
                   <a:srgbClr val="E30613"/>
                 </a:solidFill>
@@ -20743,7 +19562,7 @@
           <a:p>
             <a:pPr algn="l"/>
             <a:r>
-              <a:rPr sz="1300" b="0">
+              <a:rPr sz="1400" b="0">
                 <a:solidFill>
                   <a:srgbClr val="1A1A1A"/>
                 </a:solidFill>
@@ -20778,9 +19597,9 @@
           <a:p>
             <a:pPr algn="l"/>
             <a:r>
-              <a:rPr sz="900" b="0">
-                <a:solidFill>
-                  <a:srgbClr val="6B7280"/>
+              <a:rPr sz="1200" b="0">
+                <a:solidFill>
+                  <a:srgbClr val="1A1A1A"/>
                 </a:solidFill>
                 <a:latin typeface="Inter"/>
               </a:rPr>
@@ -20944,49 +19763,6 @@
               </a:rPr>
               <a:t>08 / 25</a:t>
             </a:r>
-          </a:p>
-        </p:txBody>
-      </p:sp>
-      <p:sp>
-        <p:nvSpPr>
-          <p:cNvPr id="21" name="Rectangle 20"/>
-          <p:cNvSpPr/>
-          <p:nvPr/>
-        </p:nvSpPr>
-        <p:spPr>
-          <a:xfrm>
-            <a:off x="0" y="0"/>
-            <a:ext cx="90000" cy="6858000"/>
-          </a:xfrm>
-          <a:prstGeom prst="rect">
-            <a:avLst/>
-          </a:prstGeom>
-          <a:solidFill>
-            <a:srgbClr val="E30613"/>
-          </a:solidFill>
-          <a:ln>
-            <a:noFill/>
-          </a:ln>
-        </p:spPr>
-        <p:style>
-          <a:lnRef idx="1">
-            <a:schemeClr val="accent1"/>
-          </a:lnRef>
-          <a:fillRef idx="3">
-            <a:schemeClr val="accent1"/>
-          </a:fillRef>
-          <a:effectRef idx="2">
-            <a:schemeClr val="accent1"/>
-          </a:effectRef>
-          <a:fontRef idx="minor">
-            <a:schemeClr val="lt1"/>
-          </a:fontRef>
-        </p:style>
-        <p:txBody>
-          <a:bodyPr rtlCol="0" anchor="ctr"/>
-          <a:lstStyle/>
-          <a:p>
-            <a:pPr algn="ctr"/>
           </a:p>
         </p:txBody>
       </p:sp>
@@ -21111,7 +19887,7 @@
           <a:p>
             <a:pPr algn="l"/>
             <a:r>
-              <a:rPr sz="2400" b="1">
+              <a:rPr sz="3000" b="1">
                 <a:solidFill>
                   <a:srgbClr val="1A1A1A"/>
                 </a:solidFill>
@@ -21146,7 +19922,7 @@
           <a:p>
             <a:pPr algn="l"/>
             <a:r>
-              <a:rPr sz="1300" b="0">
+              <a:rPr sz="1600" b="0">
                 <a:solidFill>
                   <a:srgbClr val="6B7280"/>
                 </a:solidFill>
@@ -21181,7 +19957,7 @@
           <a:p>
             <a:pPr algn="l"/>
             <a:r>
-              <a:rPr sz="1200" b="1">
+              <a:rPr sz="1100" b="1">
                 <a:solidFill>
                   <a:srgbClr val="E30613"/>
                 </a:solidFill>
@@ -21251,7 +20027,7 @@
           <a:p>
             <a:pPr algn="l"/>
             <a:r>
-              <a:rPr sz="1600" b="1">
+              <a:rPr sz="1400" b="1">
                 <a:solidFill>
                   <a:srgbClr val="E30613"/>
                 </a:solidFill>
@@ -21286,7 +20062,7 @@
           <a:p>
             <a:pPr algn="l"/>
             <a:r>
-              <a:rPr sz="1300" b="0">
+              <a:rPr sz="1400" b="0">
                 <a:solidFill>
                   <a:srgbClr val="1A1A1A"/>
                 </a:solidFill>
@@ -21321,7 +20097,7 @@
           <a:p>
             <a:pPr algn="l"/>
             <a:r>
-              <a:rPr sz="1600" b="1">
+              <a:rPr sz="1400" b="1">
                 <a:solidFill>
                   <a:srgbClr val="E30613"/>
                 </a:solidFill>
@@ -21356,7 +20132,7 @@
           <a:p>
             <a:pPr algn="l"/>
             <a:r>
-              <a:rPr sz="1300" b="0">
+              <a:rPr sz="1400" b="0">
                 <a:solidFill>
                   <a:srgbClr val="1A1A1A"/>
                 </a:solidFill>
@@ -21391,7 +20167,7 @@
           <a:p>
             <a:pPr algn="l"/>
             <a:r>
-              <a:rPr sz="1600" b="1">
+              <a:rPr sz="1400" b="1">
                 <a:solidFill>
                   <a:srgbClr val="E30613"/>
                 </a:solidFill>
@@ -21426,7 +20202,7 @@
           <a:p>
             <a:pPr algn="l"/>
             <a:r>
-              <a:rPr sz="1300" b="0">
+              <a:rPr sz="1400" b="0">
                 <a:solidFill>
                   <a:srgbClr val="1A1A1A"/>
                 </a:solidFill>
@@ -21461,7 +20237,7 @@
           <a:p>
             <a:pPr algn="l"/>
             <a:r>
-              <a:rPr sz="1600" b="1">
+              <a:rPr sz="1400" b="1">
                 <a:solidFill>
                   <a:srgbClr val="E30613"/>
                 </a:solidFill>
@@ -21496,7 +20272,7 @@
           <a:p>
             <a:pPr algn="l"/>
             <a:r>
-              <a:rPr sz="1300" b="0">
+              <a:rPr sz="1400" b="0">
                 <a:solidFill>
                   <a:srgbClr val="1A1A1A"/>
                 </a:solidFill>
@@ -21531,9 +20307,9 @@
           <a:p>
             <a:pPr algn="l"/>
             <a:r>
-              <a:rPr sz="900" b="0">
-                <a:solidFill>
-                  <a:srgbClr val="6B7280"/>
+              <a:rPr sz="1200" b="0">
+                <a:solidFill>
+                  <a:srgbClr val="1A1A1A"/>
                 </a:solidFill>
                 <a:latin typeface="Inter"/>
               </a:rPr>
@@ -21697,49 +20473,6 @@
               </a:rPr>
               <a:t>09 / 25</a:t>
             </a:r>
-          </a:p>
-        </p:txBody>
-      </p:sp>
-      <p:sp>
-        <p:nvSpPr>
-          <p:cNvPr id="21" name="Rectangle 20"/>
-          <p:cNvSpPr/>
-          <p:nvPr/>
-        </p:nvSpPr>
-        <p:spPr>
-          <a:xfrm>
-            <a:off x="0" y="0"/>
-            <a:ext cx="90000" cy="6858000"/>
-          </a:xfrm>
-          <a:prstGeom prst="rect">
-            <a:avLst/>
-          </a:prstGeom>
-          <a:solidFill>
-            <a:srgbClr val="E30613"/>
-          </a:solidFill>
-          <a:ln>
-            <a:noFill/>
-          </a:ln>
-        </p:spPr>
-        <p:style>
-          <a:lnRef idx="1">
-            <a:schemeClr val="accent1"/>
-          </a:lnRef>
-          <a:fillRef idx="3">
-            <a:schemeClr val="accent1"/>
-          </a:fillRef>
-          <a:effectRef idx="2">
-            <a:schemeClr val="accent1"/>
-          </a:effectRef>
-          <a:fontRef idx="minor">
-            <a:schemeClr val="lt1"/>
-          </a:fontRef>
-        </p:style>
-        <p:txBody>
-          <a:bodyPr rtlCol="0" anchor="ctr"/>
-          <a:lstStyle/>
-          <a:p>
-            <a:pPr algn="ctr"/>
           </a:p>
         </p:txBody>
       </p:sp>

</xml_diff>